<commit_message>
Update (객체지향프로그래밍)2026 MD_EXPO_B1_Team Icetea.pptx
</commit_message>
<xml_diff>
--- a/(객체지향프로그래밍)2026 MD_EXPO_B1_Team Icetea.pptx
+++ b/(객체지향프로그래밍)2026 MD_EXPO_B1_Team Icetea.pptx
@@ -251,7 +251,7 @@
                 <a:latin typeface="프리젠테이션 4 Regular" pitchFamily="2" charset="-127"/>
                 <a:ea typeface="프리젠테이션 4 Regular" pitchFamily="2" charset="-127"/>
               </a:rPr>
-              <a:t>2026-05-27</a:t>
+              <a:t>2026-05-28</a:t>
             </a:fld>
             <a:endParaRPr lang="ko-KR" altLang="en-US" dirty="0">
               <a:latin typeface="프리젠테이션 4 Regular" pitchFamily="2" charset="-127"/>
@@ -447,7 +447,7 @@
             <a:fld id="{7472FB17-58EF-4A58-BD0A-24A9918C23B5}" type="datetimeFigureOut">
               <a:rPr lang="ko-KR" altLang="en-US" smtClean="0"/>
               <a:pPr/>
-              <a:t>2026-05-27</a:t>
+              <a:t>2026-05-28</a:t>
             </a:fld>
             <a:endParaRPr lang="ko-KR" altLang="en-US" dirty="0"/>
           </a:p>
@@ -26215,7 +26215,7 @@
           <a:p>
             <a:fld id="{ECB7613E-18C8-4B39-A489-392B9AD58E48}" type="datetimeFigureOut">
               <a:rPr lang="ko-KR" altLang="en-US" smtClean="0"/>
-              <a:t>2026-05-27</a:t>
+              <a:t>2026-05-28</a:t>
             </a:fld>
             <a:endParaRPr lang="ko-KR" altLang="en-US"/>
           </a:p>
@@ -26643,10 +26643,10 @@
       </p:grpSpPr>
       <p:grpSp>
         <p:nvGrpSpPr>
-          <p:cNvPr id="23" name="그룹 22">
+          <p:cNvPr id="66" name="그룹 65">
             <a:extLst>
               <a:ext uri="{FF2B5EF4-FFF2-40B4-BE49-F238E27FC236}">
-                <a16:creationId xmlns:a16="http://schemas.microsoft.com/office/drawing/2014/main" id="{783A6897-3930-3114-D24B-1DD07210DF8F}"/>
+                <a16:creationId xmlns:a16="http://schemas.microsoft.com/office/drawing/2014/main" id="{A50899E1-EE43-C78B-54D4-5ED2D523E561}"/>
               </a:ext>
             </a:extLst>
           </p:cNvPr>
@@ -26655,308 +26655,652 @@
         </p:nvGrpSpPr>
         <p:grpSpPr>
           <a:xfrm>
-            <a:off x="2378290" y="5947781"/>
-            <a:ext cx="16842944" cy="4063618"/>
-            <a:chOff x="2378290" y="7131745"/>
-            <a:chExt cx="16842944" cy="4063618"/>
+            <a:off x="1510729" y="5677268"/>
+            <a:ext cx="18531245" cy="4617720"/>
+            <a:chOff x="1752216" y="5677268"/>
+            <a:chExt cx="17760514" cy="4617720"/>
           </a:xfrm>
         </p:grpSpPr>
-        <p:sp>
-          <p:nvSpPr>
-            <p:cNvPr id="121" name="TextBox 120">
+        <p:grpSp>
+          <p:nvGrpSpPr>
+            <p:cNvPr id="59" name="그룹 58">
               <a:extLst>
                 <a:ext uri="{FF2B5EF4-FFF2-40B4-BE49-F238E27FC236}">
-                  <a16:creationId xmlns:a16="http://schemas.microsoft.com/office/drawing/2014/main" id="{173918FD-6045-6171-0967-AD7D13B75CA9}"/>
+                  <a16:creationId xmlns:a16="http://schemas.microsoft.com/office/drawing/2014/main" id="{170081C2-F13F-901D-BB8C-DA4C0281BBCE}"/>
                 </a:ext>
               </a:extLst>
             </p:cNvPr>
-            <p:cNvSpPr txBox="1"/>
+            <p:cNvGrpSpPr/>
             <p:nvPr/>
-          </p:nvSpPr>
-          <p:spPr>
+          </p:nvGrpSpPr>
+          <p:grpSpPr>
             <a:xfrm>
-              <a:off x="2378290" y="8121886"/>
-              <a:ext cx="2916000" cy="769441"/>
+              <a:off x="1752216" y="5677268"/>
+              <a:ext cx="17760514" cy="4617720"/>
+              <a:chOff x="1752216" y="5677268"/>
+              <a:chExt cx="17400474" cy="4617720"/>
             </a:xfrm>
-            <a:prstGeom prst="rect">
-              <a:avLst/>
-            </a:prstGeom>
-            <a:noFill/>
-          </p:spPr>
-          <p:txBody>
-            <a:bodyPr wrap="none" lIns="72000" tIns="36000" rIns="72000" bIns="36000" rtlCol="0">
-              <a:noAutofit/>
-            </a:bodyPr>
-            <a:lstStyle/>
-            <a:p>
-              <a:r>
-                <a:rPr lang="ko-KR" altLang="en-US" sz="4400" dirty="0">
-                  <a:solidFill>
-                    <a:schemeClr val="tx1">
-                      <a:lumMod val="85000"/>
-                      <a:lumOff val="15000"/>
-                    </a:schemeClr>
-                  </a:solidFill>
-                  <a:latin typeface="페이퍼로지 6 SemiBold" pitchFamily="2" charset="-127"/>
-                  <a:ea typeface="페이퍼로지 6 SemiBold" pitchFamily="2" charset="-127"/>
-                </a:rPr>
-                <a:t>개요</a:t>
-              </a:r>
-            </a:p>
-          </p:txBody>
-        </p:sp>
-        <p:sp>
-          <p:nvSpPr>
-            <p:cNvPr id="122" name="TextBox 121">
+          </p:grpSpPr>
+          <p:sp>
+            <p:nvSpPr>
+              <p:cNvPr id="17" name="Rectangle 1038">
+                <a:extLst>
+                  <a:ext uri="{FF2B5EF4-FFF2-40B4-BE49-F238E27FC236}">
+                    <a16:creationId xmlns:a16="http://schemas.microsoft.com/office/drawing/2014/main" id="{BC557711-9E88-3735-AC61-22C516179D0B}"/>
+                  </a:ext>
+                </a:extLst>
+              </p:cNvPr>
+              <p:cNvSpPr/>
+              <p:nvPr/>
+            </p:nvSpPr>
+            <p:spPr>
+              <a:xfrm>
+                <a:off x="1752216" y="5677268"/>
+                <a:ext cx="17400474" cy="4617720"/>
+              </a:xfrm>
+              <a:prstGeom prst="rect">
+                <a:avLst/>
+              </a:prstGeom>
+              <a:solidFill>
+                <a:srgbClr val="EBF5FB"/>
+              </a:solidFill>
+              <a:ln w="19050">
+                <a:noFill/>
+              </a:ln>
+            </p:spPr>
+            <p:style>
+              <a:lnRef idx="1">
+                <a:schemeClr val="accent1"/>
+              </a:lnRef>
+              <a:fillRef idx="3">
+                <a:schemeClr val="accent1"/>
+              </a:fillRef>
+              <a:effectRef idx="2">
+                <a:schemeClr val="accent1"/>
+              </a:effectRef>
+              <a:fontRef idx="minor">
+                <a:schemeClr val="lt1"/>
+              </a:fontRef>
+            </p:style>
+            <p:txBody>
+              <a:bodyPr rtlCol="0" anchor="ctr"/>
+              <a:lstStyle/>
+              <a:p>
+                <a:pPr algn="ctr"/>
+                <a:endParaRPr dirty="0"/>
+              </a:p>
+            </p:txBody>
+          </p:sp>
+          <p:sp>
+            <p:nvSpPr>
+              <p:cNvPr id="18" name="Rectangle 1039">
+                <a:extLst>
+                  <a:ext uri="{FF2B5EF4-FFF2-40B4-BE49-F238E27FC236}">
+                    <a16:creationId xmlns:a16="http://schemas.microsoft.com/office/drawing/2014/main" id="{E187260D-0270-93FA-3B88-41515238B79E}"/>
+                  </a:ext>
+                </a:extLst>
+              </p:cNvPr>
+              <p:cNvSpPr/>
+              <p:nvPr/>
+            </p:nvSpPr>
+            <p:spPr>
+              <a:xfrm>
+                <a:off x="1752216" y="5677268"/>
+                <a:ext cx="241195" cy="4617720"/>
+              </a:xfrm>
+              <a:prstGeom prst="rect">
+                <a:avLst/>
+              </a:prstGeom>
+              <a:solidFill>
+                <a:srgbClr val="1565C0"/>
+              </a:solidFill>
+              <a:ln>
+                <a:noFill/>
+              </a:ln>
+            </p:spPr>
+            <p:style>
+              <a:lnRef idx="1">
+                <a:schemeClr val="accent1"/>
+              </a:lnRef>
+              <a:fillRef idx="3">
+                <a:schemeClr val="accent1"/>
+              </a:fillRef>
+              <a:effectRef idx="2">
+                <a:schemeClr val="accent1"/>
+              </a:effectRef>
+              <a:fontRef idx="minor">
+                <a:schemeClr val="lt1"/>
+              </a:fontRef>
+            </p:style>
+            <p:txBody>
+              <a:bodyPr rtlCol="0" anchor="ctr"/>
+              <a:lstStyle/>
+              <a:p>
+                <a:pPr algn="ctr"/>
+                <a:endParaRPr/>
+              </a:p>
+            </p:txBody>
+          </p:sp>
+          <p:sp>
+            <p:nvSpPr>
+              <p:cNvPr id="19" name="Rounded Rectangle 1046">
+                <a:extLst>
+                  <a:ext uri="{FF2B5EF4-FFF2-40B4-BE49-F238E27FC236}">
+                    <a16:creationId xmlns:a16="http://schemas.microsoft.com/office/drawing/2014/main" id="{8EA53C08-9339-C2D9-7DFA-4171A0E9635A}"/>
+                  </a:ext>
+                </a:extLst>
+              </p:cNvPr>
+              <p:cNvSpPr/>
+              <p:nvPr/>
+            </p:nvSpPr>
+            <p:spPr>
+              <a:xfrm>
+                <a:off x="2462567" y="5926658"/>
+                <a:ext cx="900000" cy="900000"/>
+              </a:xfrm>
+              <a:prstGeom prst="roundRect">
+                <a:avLst>
+                  <a:gd name="adj" fmla="val 8000"/>
+                </a:avLst>
+              </a:prstGeom>
+              <a:solidFill>
+                <a:srgbClr val="1565C0"/>
+              </a:solidFill>
+              <a:ln>
+                <a:noFill/>
+              </a:ln>
+            </p:spPr>
+            <p:style>
+              <a:lnRef idx="1">
+                <a:schemeClr val="accent1"/>
+              </a:lnRef>
+              <a:fillRef idx="3">
+                <a:schemeClr val="accent1"/>
+              </a:fillRef>
+              <a:effectRef idx="2">
+                <a:schemeClr val="accent1"/>
+              </a:effectRef>
+              <a:fontRef idx="minor">
+                <a:schemeClr val="lt1"/>
+              </a:fontRef>
+            </p:style>
+            <p:txBody>
+              <a:bodyPr rtlCol="0" anchor="ctr"/>
+              <a:lstStyle/>
+              <a:p>
+                <a:pPr algn="ctr"/>
+                <a:endParaRPr/>
+              </a:p>
+            </p:txBody>
+          </p:sp>
+          <p:sp>
+            <p:nvSpPr>
+              <p:cNvPr id="21" name="Diamond 1073">
+                <a:extLst>
+                  <a:ext uri="{FF2B5EF4-FFF2-40B4-BE49-F238E27FC236}">
+                    <a16:creationId xmlns:a16="http://schemas.microsoft.com/office/drawing/2014/main" id="{359E277E-BCE2-1688-3FA6-FA89C8B4397D}"/>
+                  </a:ext>
+                </a:extLst>
+              </p:cNvPr>
+              <p:cNvSpPr/>
+              <p:nvPr/>
+            </p:nvSpPr>
+            <p:spPr>
+              <a:xfrm>
+                <a:off x="18549703" y="6454508"/>
+                <a:ext cx="344564" cy="365760"/>
+              </a:xfrm>
+              <a:prstGeom prst="diamond">
+                <a:avLst/>
+              </a:prstGeom>
+              <a:solidFill>
+                <a:schemeClr val="accent2"/>
+              </a:solidFill>
+              <a:ln>
+                <a:noFill/>
+              </a:ln>
+            </p:spPr>
+            <p:style>
+              <a:lnRef idx="1">
+                <a:schemeClr val="accent1"/>
+              </a:lnRef>
+              <a:fillRef idx="3">
+                <a:schemeClr val="accent1"/>
+              </a:fillRef>
+              <a:effectRef idx="2">
+                <a:schemeClr val="accent1"/>
+              </a:effectRef>
+              <a:fontRef idx="minor">
+                <a:schemeClr val="lt1"/>
+              </a:fontRef>
+            </p:style>
+            <p:txBody>
+              <a:bodyPr rtlCol="0" anchor="ctr"/>
+              <a:lstStyle/>
+              <a:p>
+                <a:pPr algn="ctr"/>
+                <a:endParaRPr/>
+              </a:p>
+            </p:txBody>
+          </p:sp>
+          <p:sp>
+            <p:nvSpPr>
+              <p:cNvPr id="22" name="Rounded Rectangle 1074">
+                <a:extLst>
+                  <a:ext uri="{FF2B5EF4-FFF2-40B4-BE49-F238E27FC236}">
+                    <a16:creationId xmlns:a16="http://schemas.microsoft.com/office/drawing/2014/main" id="{5FF2B708-4015-0111-D3AF-D7A1FF68DFB4}"/>
+                  </a:ext>
+                </a:extLst>
+              </p:cNvPr>
+              <p:cNvSpPr/>
+              <p:nvPr/>
+            </p:nvSpPr>
+            <p:spPr>
+              <a:xfrm>
+                <a:off x="18618616" y="7551787"/>
+                <a:ext cx="223966" cy="237744"/>
+              </a:xfrm>
+              <a:prstGeom prst="roundRect">
+                <a:avLst/>
+              </a:prstGeom>
+              <a:solidFill>
+                <a:srgbClr val="90CAF9"/>
+              </a:solidFill>
+              <a:ln>
+                <a:noFill/>
+              </a:ln>
+            </p:spPr>
+            <p:style>
+              <a:lnRef idx="1">
+                <a:schemeClr val="accent1"/>
+              </a:lnRef>
+              <a:fillRef idx="3">
+                <a:schemeClr val="accent1"/>
+              </a:fillRef>
+              <a:effectRef idx="2">
+                <a:schemeClr val="accent1"/>
+              </a:effectRef>
+              <a:fontRef idx="minor">
+                <a:schemeClr val="lt1"/>
+              </a:fontRef>
+            </p:style>
+            <p:txBody>
+              <a:bodyPr rtlCol="0" anchor="ctr"/>
+              <a:lstStyle/>
+              <a:p>
+                <a:pPr algn="ctr"/>
+                <a:endParaRPr/>
+              </a:p>
+            </p:txBody>
+          </p:sp>
+          <p:sp>
+            <p:nvSpPr>
+              <p:cNvPr id="24" name="Rectangle 1075">
+                <a:extLst>
+                  <a:ext uri="{FF2B5EF4-FFF2-40B4-BE49-F238E27FC236}">
+                    <a16:creationId xmlns:a16="http://schemas.microsoft.com/office/drawing/2014/main" id="{A8EF866B-C43F-54C1-175E-4597A9FF67F1}"/>
+                  </a:ext>
+                </a:extLst>
+              </p:cNvPr>
+              <p:cNvSpPr/>
+              <p:nvPr/>
+            </p:nvSpPr>
+            <p:spPr>
+              <a:xfrm>
+                <a:off x="18653072" y="8557628"/>
+                <a:ext cx="155054" cy="164592"/>
+              </a:xfrm>
+              <a:prstGeom prst="rect">
+                <a:avLst/>
+              </a:prstGeom>
+              <a:solidFill>
+                <a:srgbClr val="BBDEFB"/>
+              </a:solidFill>
+              <a:ln>
+                <a:noFill/>
+              </a:ln>
+            </p:spPr>
+            <p:style>
+              <a:lnRef idx="1">
+                <a:schemeClr val="accent1"/>
+              </a:lnRef>
+              <a:fillRef idx="3">
+                <a:schemeClr val="accent1"/>
+              </a:fillRef>
+              <a:effectRef idx="2">
+                <a:schemeClr val="accent1"/>
+              </a:effectRef>
+              <a:fontRef idx="minor">
+                <a:schemeClr val="lt1"/>
+              </a:fontRef>
+            </p:style>
+            <p:txBody>
+              <a:bodyPr rtlCol="0" anchor="ctr"/>
+              <a:lstStyle/>
+              <a:p>
+                <a:pPr algn="ctr"/>
+                <a:endParaRPr/>
+              </a:p>
+            </p:txBody>
+          </p:sp>
+        </p:grpSp>
+        <p:grpSp>
+          <p:nvGrpSpPr>
+            <p:cNvPr id="23" name="그룹 22">
               <a:extLst>
                 <a:ext uri="{FF2B5EF4-FFF2-40B4-BE49-F238E27FC236}">
-                  <a16:creationId xmlns:a16="http://schemas.microsoft.com/office/drawing/2014/main" id="{AA11B264-2776-37C0-2D7A-E304C366DFDD}"/>
+                  <a16:creationId xmlns:a16="http://schemas.microsoft.com/office/drawing/2014/main" id="{783A6897-3930-3114-D24B-1DD07210DF8F}"/>
                 </a:ext>
               </a:extLst>
             </p:cNvPr>
-            <p:cNvSpPr txBox="1"/>
+            <p:cNvGrpSpPr/>
             <p:nvPr/>
-          </p:nvSpPr>
-          <p:spPr>
+          </p:nvGrpSpPr>
+          <p:grpSpPr>
             <a:xfrm>
-              <a:off x="2378290" y="7131745"/>
-              <a:ext cx="1006032" cy="831517"/>
+              <a:off x="2374826" y="5919877"/>
+              <a:ext cx="16468863" cy="4091522"/>
+              <a:chOff x="2378290" y="7103841"/>
+              <a:chExt cx="16468863" cy="4091522"/>
             </a:xfrm>
-            <a:prstGeom prst="rect">
-              <a:avLst/>
-            </a:prstGeom>
-            <a:noFill/>
-          </p:spPr>
-          <p:txBody>
-            <a:bodyPr wrap="none" rtlCol="0" anchor="ctr">
-              <a:spAutoFit/>
-            </a:bodyPr>
-            <a:lstStyle/>
-            <a:p>
-              <a:r>
-                <a:rPr lang="en-US" altLang="ko-KR" sz="4800" dirty="0">
+          </p:grpSpPr>
+          <p:sp>
+            <p:nvSpPr>
+              <p:cNvPr id="121" name="TextBox 120">
+                <a:extLst>
+                  <a:ext uri="{FF2B5EF4-FFF2-40B4-BE49-F238E27FC236}">
+                    <a16:creationId xmlns:a16="http://schemas.microsoft.com/office/drawing/2014/main" id="{173918FD-6045-6171-0967-AD7D13B75CA9}"/>
+                  </a:ext>
+                </a:extLst>
+              </p:cNvPr>
+              <p:cNvSpPr txBox="1"/>
+              <p:nvPr/>
+            </p:nvSpPr>
+            <p:spPr>
+              <a:xfrm>
+                <a:off x="2378290" y="8121886"/>
+                <a:ext cx="2916000" cy="769441"/>
+              </a:xfrm>
+              <a:prstGeom prst="rect">
+                <a:avLst/>
+              </a:prstGeom>
+              <a:noFill/>
+            </p:spPr>
+            <p:txBody>
+              <a:bodyPr wrap="none" lIns="72000" tIns="36000" rIns="72000" bIns="36000" rtlCol="0">
+                <a:noAutofit/>
+              </a:bodyPr>
+              <a:lstStyle/>
+              <a:p>
+                <a:r>
+                  <a:rPr lang="ko-KR" altLang="en-US" sz="4400" dirty="0">
+                    <a:solidFill>
+                      <a:schemeClr val="tx1">
+                        <a:lumMod val="85000"/>
+                        <a:lumOff val="15000"/>
+                      </a:schemeClr>
+                    </a:solidFill>
+                    <a:latin typeface="페이퍼로지 6 SemiBold" pitchFamily="2" charset="-127"/>
+                    <a:ea typeface="페이퍼로지 6 SemiBold" pitchFamily="2" charset="-127"/>
+                  </a:rPr>
+                  <a:t>개요</a:t>
+                </a:r>
+              </a:p>
+            </p:txBody>
+          </p:sp>
+          <p:sp>
+            <p:nvSpPr>
+              <p:cNvPr id="122" name="TextBox 121">
+                <a:extLst>
+                  <a:ext uri="{FF2B5EF4-FFF2-40B4-BE49-F238E27FC236}">
+                    <a16:creationId xmlns:a16="http://schemas.microsoft.com/office/drawing/2014/main" id="{AA11B264-2776-37C0-2D7A-E304C366DFDD}"/>
+                  </a:ext>
+                </a:extLst>
+              </p:cNvPr>
+              <p:cNvSpPr txBox="1"/>
+              <p:nvPr/>
+            </p:nvSpPr>
+            <p:spPr>
+              <a:xfrm>
+                <a:off x="2446835" y="7103841"/>
+                <a:ext cx="1006032" cy="831517"/>
+              </a:xfrm>
+              <a:prstGeom prst="rect">
+                <a:avLst/>
+              </a:prstGeom>
+              <a:noFill/>
+            </p:spPr>
+            <p:txBody>
+              <a:bodyPr wrap="none" rtlCol="0" anchor="ctr">
+                <a:spAutoFit/>
+              </a:bodyPr>
+              <a:lstStyle/>
+              <a:p>
+                <a:r>
+                  <a:rPr lang="en-US" altLang="ko-KR" sz="4800" dirty="0">
+                    <a:solidFill>
+                      <a:schemeClr val="accent2"/>
+                    </a:solidFill>
+                    <a:latin typeface="페이퍼로지 8 ExtraBold" pitchFamily="2" charset="-127"/>
+                    <a:ea typeface="페이퍼로지 8 ExtraBold" pitchFamily="2" charset="-127"/>
+                  </a:rPr>
+                  <a:t>01</a:t>
+                </a:r>
+                <a:endParaRPr lang="ko-KR" altLang="en-US" sz="4800" dirty="0">
                   <a:solidFill>
                     <a:schemeClr val="accent2"/>
                   </a:solidFill>
                   <a:latin typeface="페이퍼로지 8 ExtraBold" pitchFamily="2" charset="-127"/>
                   <a:ea typeface="페이퍼로지 8 ExtraBold" pitchFamily="2" charset="-127"/>
-                </a:rPr>
-                <a:t>01</a:t>
-              </a:r>
-              <a:endParaRPr lang="ko-KR" altLang="en-US" sz="4800" dirty="0">
+                </a:endParaRPr>
+              </a:p>
+            </p:txBody>
+          </p:sp>
+          <p:sp>
+            <p:nvSpPr>
+              <p:cNvPr id="32" name="TextBox 31">
+                <a:extLst>
+                  <a:ext uri="{FF2B5EF4-FFF2-40B4-BE49-F238E27FC236}">
+                    <a16:creationId xmlns:a16="http://schemas.microsoft.com/office/drawing/2014/main" id="{07364066-598E-189C-A9CC-CCF3620ABFA1}"/>
+                  </a:ext>
+                </a:extLst>
+              </p:cNvPr>
+              <p:cNvSpPr txBox="1"/>
+              <p:nvPr/>
+            </p:nvSpPr>
+            <p:spPr>
+              <a:xfrm>
+                <a:off x="6034494" y="7201272"/>
+                <a:ext cx="12812659" cy="3994091"/>
+              </a:xfrm>
+              <a:prstGeom prst="rect">
+                <a:avLst/>
+              </a:prstGeom>
+              <a:noFill/>
+            </p:spPr>
+            <p:txBody>
+              <a:bodyPr wrap="square" lIns="72000" tIns="36000" rIns="72000" bIns="36000" rtlCol="0" anchor="t">
+                <a:normAutofit/>
+              </a:bodyPr>
+              <a:lstStyle/>
+              <a:p>
+                <a:pPr marL="720000" marR="0" lvl="0" indent="-720000" algn="l" defTabSz="2159996" rtl="0" eaLnBrk="1" fontAlgn="auto" latinLnBrk="1" hangingPunct="1">
+                  <a:spcAft>
+                    <a:spcPts val="1200"/>
+                  </a:spcAft>
+                  <a:buClr>
+                    <a:schemeClr val="accent2"/>
+                  </a:buClr>
+                  <a:buSzTx/>
+                  <a:buFont typeface="프리젠테이션 4 Regular" pitchFamily="2" charset="-127"/>
+                  <a:buChar char=""/>
+                </a:pPr>
+                <a:r>
+                  <a:rPr lang="ko-KR" altLang="en-US" sz="4000" dirty="0">
+                    <a:solidFill>
+                      <a:schemeClr val="tx1">
+                        <a:lumMod val="95000"/>
+                        <a:lumOff val="5000"/>
+                      </a:schemeClr>
+                    </a:solidFill>
+                  </a:rPr>
+                  <a:t>C++ 기반 텍스트 콘솔 오프라인 문제은행 프로그램</a:t>
+                </a:r>
+              </a:p>
+              <a:p>
+                <a:pPr marL="720000" marR="0" lvl="0" indent="-720000" algn="l" defTabSz="2159996" rtl="0" eaLnBrk="1" fontAlgn="auto" latinLnBrk="1" hangingPunct="1">
+                  <a:spcAft>
+                    <a:spcPts val="1200"/>
+                  </a:spcAft>
+                  <a:buClr>
+                    <a:schemeClr val="accent2"/>
+                  </a:buClr>
+                  <a:buSzTx/>
+                  <a:buFont typeface="프리젠테이션 4 Regular" pitchFamily="2" charset="-127"/>
+                  <a:buChar char=""/>
+                </a:pPr>
+                <a:r>
+                  <a:rPr lang="ko-KR" altLang="en-US" sz="4000" dirty="0">
+                    <a:solidFill>
+                      <a:schemeClr val="tx1">
+                        <a:lumMod val="95000"/>
+                        <a:lumOff val="5000"/>
+                      </a:schemeClr>
+                    </a:solidFill>
+                  </a:rPr>
+                  <a:t>ASCII 아트 UI · 방향키/Enter 조작, 직관적인 메뉴 구조</a:t>
+                </a:r>
+              </a:p>
+              <a:p>
+                <a:pPr marL="720000" marR="0" lvl="0" indent="-720000" algn="l" defTabSz="2159996" rtl="0" eaLnBrk="1" fontAlgn="auto" latinLnBrk="1" hangingPunct="1">
+                  <a:spcAft>
+                    <a:spcPts val="1200"/>
+                  </a:spcAft>
+                  <a:buClr>
+                    <a:schemeClr val="accent2"/>
+                  </a:buClr>
+                  <a:buSzTx/>
+                  <a:buFont typeface="프리젠테이션 4 Regular" pitchFamily="2" charset="-127"/>
+                  <a:buChar char=""/>
+                </a:pPr>
+                <a:r>
+                  <a:rPr lang="ko-KR" altLang="en-US" sz="4000" dirty="0">
+                    <a:solidFill>
+                      <a:schemeClr val="tx1">
+                        <a:lumMod val="95000"/>
+                        <a:lumOff val="5000"/>
+                      </a:schemeClr>
+                    </a:solidFill>
+                  </a:rPr>
+                  <a:t>CSV 파일로 과목별 문제 관리 · 과목 선택 메뉴 제공</a:t>
+                </a:r>
+              </a:p>
+              <a:p>
+                <a:pPr marL="720000" marR="0" lvl="0" indent="-720000" algn="l" defTabSz="2159996" rtl="0" eaLnBrk="1" fontAlgn="auto" latinLnBrk="1" hangingPunct="1">
+                  <a:spcAft>
+                    <a:spcPts val="1200"/>
+                  </a:spcAft>
+                  <a:buClr>
+                    <a:schemeClr val="accent2"/>
+                  </a:buClr>
+                  <a:buSzTx/>
+                  <a:buFont typeface="프리젠테이션 4 Regular" pitchFamily="2" charset="-127"/>
+                  <a:buChar char=""/>
+                </a:pPr>
+                <a:r>
+                  <a:rPr lang="ko-KR" altLang="en-US" sz="4000" dirty="0">
+                    <a:solidFill>
+                      <a:schemeClr val="tx1">
+                        <a:lumMod val="95000"/>
+                        <a:lumOff val="5000"/>
+                      </a:schemeClr>
+                    </a:solidFill>
+                  </a:rPr>
+                  <a:t>연습 · 시험 · 게임 · 검색 · 문제 제작 총 5가지 모드</a:t>
+                </a:r>
+              </a:p>
+              <a:p>
+                <a:pPr marL="720000" marR="0" lvl="0" indent="-720000" algn="l" defTabSz="2159996" rtl="0" eaLnBrk="1" fontAlgn="auto" latinLnBrk="1" hangingPunct="1">
+                  <a:spcAft>
+                    <a:spcPts val="1200"/>
+                  </a:spcAft>
+                  <a:buClr>
+                    <a:schemeClr val="accent2"/>
+                  </a:buClr>
+                  <a:buSzTx/>
+                  <a:buFont typeface="프리젠테이션 4 Regular" pitchFamily="2" charset="-127"/>
+                  <a:buChar char=""/>
+                </a:pPr>
+                <a:r>
+                  <a:rPr lang="ko-KR" altLang="en-US" sz="4000" dirty="0">
+                    <a:solidFill>
+                      <a:schemeClr val="tx1">
+                        <a:lumMod val="95000"/>
+                        <a:lumOff val="5000"/>
+                      </a:schemeClr>
+                    </a:solidFill>
+                  </a:rPr>
+                  <a:t>오프라인 환경에서 동작하는 실행 파일(.exe) 배포</a:t>
+                </a:r>
+              </a:p>
+            </p:txBody>
+          </p:sp>
+          <p:cxnSp>
+            <p:nvCxnSpPr>
+              <p:cNvPr id="125" name="직선 연결선 124">
+                <a:extLst>
+                  <a:ext uri="{FF2B5EF4-FFF2-40B4-BE49-F238E27FC236}">
+                    <a16:creationId xmlns:a16="http://schemas.microsoft.com/office/drawing/2014/main" id="{E4788783-5FE8-0E4A-4B66-9522FCF33DE4}"/>
+                  </a:ext>
+                </a:extLst>
+              </p:cNvPr>
+              <p:cNvCxnSpPr>
+                <a:cxnSpLocks/>
+              </p:cNvCxnSpPr>
+              <p:nvPr/>
+            </p:nvCxnSpPr>
+            <p:spPr>
+              <a:xfrm>
+                <a:off x="3923539" y="7547503"/>
+                <a:ext cx="2004816" cy="0"/>
+              </a:xfrm>
+              <a:prstGeom prst="line">
+                <a:avLst/>
+              </a:prstGeom>
+              <a:ln w="47625" cap="rnd">
                 <a:solidFill>
-                  <a:schemeClr val="accent2"/>
+                  <a:schemeClr val="tx2">
+                    <a:lumMod val="40000"/>
+                    <a:lumOff val="60000"/>
+                  </a:schemeClr>
                 </a:solidFill>
-                <a:latin typeface="페이퍼로지 8 ExtraBold" pitchFamily="2" charset="-127"/>
-                <a:ea typeface="페이퍼로지 8 ExtraBold" pitchFamily="2" charset="-127"/>
-              </a:endParaRPr>
-            </a:p>
-          </p:txBody>
-        </p:sp>
-        <p:sp>
-          <p:nvSpPr>
-            <p:cNvPr id="32" name="TextBox 31">
-              <a:extLst>
-                <a:ext uri="{FF2B5EF4-FFF2-40B4-BE49-F238E27FC236}">
-                  <a16:creationId xmlns:a16="http://schemas.microsoft.com/office/drawing/2014/main" id="{07364066-598E-189C-A9CC-CCF3620ABFA1}"/>
-                </a:ext>
-              </a:extLst>
-            </p:cNvPr>
-            <p:cNvSpPr txBox="1"/>
-            <p:nvPr/>
-          </p:nvSpPr>
-          <p:spPr>
-            <a:xfrm>
-              <a:off x="6408575" y="7201272"/>
-              <a:ext cx="12812659" cy="3994091"/>
-            </a:xfrm>
-            <a:prstGeom prst="rect">
-              <a:avLst/>
-            </a:prstGeom>
-            <a:noFill/>
-          </p:spPr>
-          <p:txBody>
-            <a:bodyPr wrap="square" lIns="72000" tIns="36000" rIns="72000" bIns="36000" rtlCol="0" anchor="t">
-              <a:normAutofit/>
-            </a:bodyPr>
-            <a:lstStyle/>
-            <a:p>
-              <a:pPr marL="720000" marR="0" lvl="0" indent="-720000" algn="l" defTabSz="2159996" rtl="0" eaLnBrk="1" fontAlgn="auto" latinLnBrk="1" hangingPunct="1">
-                <a:spcAft>
-                  <a:spcPts val="1200"/>
-                </a:spcAft>
-                <a:buClr>
-                  <a:schemeClr val="accent2"/>
-                </a:buClr>
-                <a:buSzTx/>
-                <a:buFont typeface="프리젠테이션 4 Regular" pitchFamily="2" charset="-127"/>
-                <a:buChar char=""/>
-              </a:pPr>
-              <a:r>
-                <a:rPr lang="ko-KR" altLang="en-US" sz="4000" dirty="0">
-                  <a:solidFill>
-                    <a:schemeClr val="tx1">
-                      <a:lumMod val="95000"/>
-                      <a:lumOff val="5000"/>
-                    </a:schemeClr>
-                  </a:solidFill>
-                </a:rPr>
-                <a:t>C++ 기반 텍스트 콘솔 오프라인 문제은행 프로그램</a:t>
-              </a:r>
-            </a:p>
-            <a:p>
-              <a:pPr marL="720000" marR="0" lvl="0" indent="-720000" algn="l" defTabSz="2159996" rtl="0" eaLnBrk="1" fontAlgn="auto" latinLnBrk="1" hangingPunct="1">
-                <a:spcAft>
-                  <a:spcPts val="1200"/>
-                </a:spcAft>
-                <a:buClr>
-                  <a:schemeClr val="accent2"/>
-                </a:buClr>
-                <a:buSzTx/>
-                <a:buFont typeface="프리젠테이션 4 Regular" pitchFamily="2" charset="-127"/>
-                <a:buChar char=""/>
-              </a:pPr>
-              <a:r>
-                <a:rPr lang="ko-KR" altLang="en-US" sz="4000" dirty="0">
-                  <a:solidFill>
-                    <a:schemeClr val="tx1">
-                      <a:lumMod val="95000"/>
-                      <a:lumOff val="5000"/>
-                    </a:schemeClr>
-                  </a:solidFill>
-                </a:rPr>
-                <a:t>ASCII 아트 UI · 방향키/Enter 조작, 직관적인 메뉴 구조</a:t>
-              </a:r>
-            </a:p>
-            <a:p>
-              <a:pPr marL="720000" marR="0" lvl="0" indent="-720000" algn="l" defTabSz="2159996" rtl="0" eaLnBrk="1" fontAlgn="auto" latinLnBrk="1" hangingPunct="1">
-                <a:spcAft>
-                  <a:spcPts val="1200"/>
-                </a:spcAft>
-                <a:buClr>
-                  <a:schemeClr val="accent2"/>
-                </a:buClr>
-                <a:buSzTx/>
-                <a:buFont typeface="프리젠테이션 4 Regular" pitchFamily="2" charset="-127"/>
-                <a:buChar char=""/>
-              </a:pPr>
-              <a:r>
-                <a:rPr lang="ko-KR" altLang="en-US" sz="4000" dirty="0">
-                  <a:solidFill>
-                    <a:schemeClr val="tx1">
-                      <a:lumMod val="95000"/>
-                      <a:lumOff val="5000"/>
-                    </a:schemeClr>
-                  </a:solidFill>
-                </a:rPr>
-                <a:t>CSV 파일로 과목별 문제 관리 · 과목 선택 메뉴 제공</a:t>
-              </a:r>
-            </a:p>
-            <a:p>
-              <a:pPr marL="720000" marR="0" lvl="0" indent="-720000" algn="l" defTabSz="2159996" rtl="0" eaLnBrk="1" fontAlgn="auto" latinLnBrk="1" hangingPunct="1">
-                <a:spcAft>
-                  <a:spcPts val="1200"/>
-                </a:spcAft>
-                <a:buClr>
-                  <a:schemeClr val="accent2"/>
-                </a:buClr>
-                <a:buSzTx/>
-                <a:buFont typeface="프리젠테이션 4 Regular" pitchFamily="2" charset="-127"/>
-                <a:buChar char=""/>
-              </a:pPr>
-              <a:r>
-                <a:rPr lang="ko-KR" altLang="en-US" sz="4000" dirty="0">
-                  <a:solidFill>
-                    <a:schemeClr val="tx1">
-                      <a:lumMod val="95000"/>
-                      <a:lumOff val="5000"/>
-                    </a:schemeClr>
-                  </a:solidFill>
-                </a:rPr>
-                <a:t>연습 · 시험 · 게임 · 검색 · 문제 제작 총 5가지 모드</a:t>
-              </a:r>
-            </a:p>
-            <a:p>
-              <a:pPr marL="720000" marR="0" lvl="0" indent="-720000" algn="l" defTabSz="2159996" rtl="0" eaLnBrk="1" fontAlgn="auto" latinLnBrk="1" hangingPunct="1">
-                <a:spcAft>
-                  <a:spcPts val="1200"/>
-                </a:spcAft>
-                <a:buClr>
-                  <a:schemeClr val="accent2"/>
-                </a:buClr>
-                <a:buSzTx/>
-                <a:buFont typeface="프리젠테이션 4 Regular" pitchFamily="2" charset="-127"/>
-                <a:buChar char=""/>
-              </a:pPr>
-              <a:r>
-                <a:rPr lang="ko-KR" altLang="en-US" sz="4000" dirty="0">
-                  <a:solidFill>
-                    <a:schemeClr val="tx1">
-                      <a:lumMod val="95000"/>
-                      <a:lumOff val="5000"/>
-                    </a:schemeClr>
-                  </a:solidFill>
-                </a:rPr>
-                <a:t>오프라인 환경에서 동작하는 실행 파일(.exe) 배포</a:t>
-              </a:r>
-            </a:p>
-          </p:txBody>
-        </p:sp>
-        <p:cxnSp>
-          <p:nvCxnSpPr>
-            <p:cNvPr id="125" name="직선 연결선 124">
-              <a:extLst>
-                <a:ext uri="{FF2B5EF4-FFF2-40B4-BE49-F238E27FC236}">
-                  <a16:creationId xmlns:a16="http://schemas.microsoft.com/office/drawing/2014/main" id="{E4788783-5FE8-0E4A-4B66-9522FCF33DE4}"/>
-                </a:ext>
-              </a:extLst>
-            </p:cNvPr>
-            <p:cNvCxnSpPr>
-              <a:cxnSpLocks/>
-            </p:cNvCxnSpPr>
-            <p:nvPr/>
-          </p:nvCxnSpPr>
-          <p:spPr>
-            <a:xfrm>
-              <a:off x="3923539" y="7547503"/>
-              <a:ext cx="2004816" cy="0"/>
-            </a:xfrm>
-            <a:prstGeom prst="line">
-              <a:avLst/>
-            </a:prstGeom>
-            <a:ln w="47625" cap="rnd">
-              <a:solidFill>
-                <a:schemeClr val="tx2">
-                  <a:lumMod val="40000"/>
-                  <a:lumOff val="60000"/>
-                </a:schemeClr>
-              </a:solidFill>
-              <a:prstDash val="sysDot"/>
-              <a:round/>
-            </a:ln>
-          </p:spPr>
-          <p:style>
-            <a:lnRef idx="1">
-              <a:schemeClr val="accent1"/>
-            </a:lnRef>
-            <a:fillRef idx="0">
-              <a:schemeClr val="accent1"/>
-            </a:fillRef>
-            <a:effectRef idx="0">
-              <a:schemeClr val="accent1"/>
-            </a:effectRef>
-            <a:fontRef idx="minor">
-              <a:schemeClr val="tx1"/>
-            </a:fontRef>
-          </p:style>
-        </p:cxnSp>
+                <a:prstDash val="sysDot"/>
+                <a:round/>
+              </a:ln>
+            </p:spPr>
+            <p:style>
+              <a:lnRef idx="1">
+                <a:schemeClr val="accent1"/>
+              </a:lnRef>
+              <a:fillRef idx="0">
+                <a:schemeClr val="accent1"/>
+              </a:fillRef>
+              <a:effectRef idx="0">
+                <a:schemeClr val="accent1"/>
+              </a:effectRef>
+              <a:fontRef idx="minor">
+                <a:schemeClr val="tx1"/>
+              </a:fontRef>
+            </p:style>
+          </p:cxnSp>
+        </p:grpSp>
       </p:grpSp>
       <p:grpSp>
         <p:nvGrpSpPr>
-          <p:cNvPr id="13" name="그룹 12">
+          <p:cNvPr id="65" name="그룹 64">
             <a:extLst>
               <a:ext uri="{FF2B5EF4-FFF2-40B4-BE49-F238E27FC236}">
-                <a16:creationId xmlns:a16="http://schemas.microsoft.com/office/drawing/2014/main" id="{1C89CAF0-B002-E2F4-8AC0-C8DD99029697}"/>
+                <a16:creationId xmlns:a16="http://schemas.microsoft.com/office/drawing/2014/main" id="{AA42ACDB-3C3C-E944-4450-DFE17EA345E1}"/>
               </a:ext>
             </a:extLst>
           </p:cNvPr>
@@ -26965,284 +27309,628 @@
         </p:nvGrpSpPr>
         <p:grpSpPr>
           <a:xfrm>
-            <a:off x="2437287" y="10233589"/>
-            <a:ext cx="16783947" cy="3663163"/>
-            <a:chOff x="2437287" y="11598304"/>
-            <a:chExt cx="16783947" cy="3663163"/>
+            <a:off x="1510729" y="10092420"/>
+            <a:ext cx="18531245" cy="4206240"/>
+            <a:chOff x="1752216" y="10092420"/>
+            <a:chExt cx="17760514" cy="4206240"/>
           </a:xfrm>
         </p:grpSpPr>
-        <p:sp>
-          <p:nvSpPr>
-            <p:cNvPr id="1030" name="TextBox 1029">
+        <p:grpSp>
+          <p:nvGrpSpPr>
+            <p:cNvPr id="60" name="그룹 59">
               <a:extLst>
                 <a:ext uri="{FF2B5EF4-FFF2-40B4-BE49-F238E27FC236}">
-                  <a16:creationId xmlns:a16="http://schemas.microsoft.com/office/drawing/2014/main" id="{13DF435A-D740-D33E-5AB2-C49EA72C4DB0}"/>
+                  <a16:creationId xmlns:a16="http://schemas.microsoft.com/office/drawing/2014/main" id="{0C81371F-9A64-605E-430C-397D09B8AB35}"/>
                 </a:ext>
               </a:extLst>
             </p:cNvPr>
-            <p:cNvSpPr txBox="1"/>
+            <p:cNvGrpSpPr/>
             <p:nvPr/>
-          </p:nvSpPr>
-          <p:spPr>
+          </p:nvGrpSpPr>
+          <p:grpSpPr>
             <a:xfrm>
-              <a:off x="2437287" y="12588447"/>
-              <a:ext cx="2916000" cy="769441"/>
+              <a:off x="1752216" y="10092420"/>
+              <a:ext cx="17760514" cy="4206240"/>
+              <a:chOff x="1752216" y="10092420"/>
+              <a:chExt cx="17400474" cy="4206240"/>
             </a:xfrm>
-            <a:prstGeom prst="rect">
-              <a:avLst/>
-            </a:prstGeom>
-            <a:noFill/>
-          </p:spPr>
-          <p:txBody>
-            <a:bodyPr wrap="none" lIns="72000" tIns="36000" rIns="72000" bIns="36000" rtlCol="0">
-              <a:noAutofit/>
-            </a:bodyPr>
-            <a:lstStyle/>
-            <a:p>
-              <a:r>
-                <a:rPr lang="ko-KR" altLang="en-US" sz="4400" dirty="0">
-                  <a:solidFill>
-                    <a:schemeClr val="tx1">
-                      <a:lumMod val="85000"/>
-                      <a:lumOff val="15000"/>
-                    </a:schemeClr>
-                  </a:solidFill>
-                  <a:latin typeface="페이퍼로지 6 SemiBold" pitchFamily="2" charset="-127"/>
-                  <a:ea typeface="페이퍼로지 6 SemiBold" pitchFamily="2" charset="-127"/>
-                </a:rPr>
-                <a:t>배경 및 목적</a:t>
-              </a:r>
-            </a:p>
-          </p:txBody>
-        </p:sp>
-        <p:sp>
-          <p:nvSpPr>
-            <p:cNvPr id="1031" name="TextBox 1030">
+          </p:grpSpPr>
+          <p:sp>
+            <p:nvSpPr>
+              <p:cNvPr id="53" name="Rectangle 1040">
+                <a:extLst>
+                  <a:ext uri="{FF2B5EF4-FFF2-40B4-BE49-F238E27FC236}">
+                    <a16:creationId xmlns:a16="http://schemas.microsoft.com/office/drawing/2014/main" id="{B7263E1D-8A80-BB94-3206-191EB1BC4240}"/>
+                  </a:ext>
+                </a:extLst>
+              </p:cNvPr>
+              <p:cNvSpPr/>
+              <p:nvPr/>
+            </p:nvSpPr>
+            <p:spPr>
+              <a:xfrm>
+                <a:off x="1752216" y="10092420"/>
+                <a:ext cx="17400474" cy="4206240"/>
+              </a:xfrm>
+              <a:prstGeom prst="rect">
+                <a:avLst/>
+              </a:prstGeom>
+              <a:solidFill>
+                <a:srgbClr val="FEF9E7"/>
+              </a:solidFill>
+              <a:ln w="19050">
+                <a:noFill/>
+              </a:ln>
+            </p:spPr>
+            <p:style>
+              <a:lnRef idx="1">
+                <a:schemeClr val="accent1"/>
+              </a:lnRef>
+              <a:fillRef idx="3">
+                <a:schemeClr val="accent1"/>
+              </a:fillRef>
+              <a:effectRef idx="2">
+                <a:schemeClr val="accent1"/>
+              </a:effectRef>
+              <a:fontRef idx="minor">
+                <a:schemeClr val="lt1"/>
+              </a:fontRef>
+            </p:style>
+            <p:txBody>
+              <a:bodyPr rtlCol="0" anchor="ctr"/>
+              <a:lstStyle/>
+              <a:p>
+                <a:pPr algn="ctr"/>
+                <a:endParaRPr dirty="0"/>
+              </a:p>
+            </p:txBody>
+          </p:sp>
+          <p:sp>
+            <p:nvSpPr>
+              <p:cNvPr id="54" name="Rectangle 1041">
+                <a:extLst>
+                  <a:ext uri="{FF2B5EF4-FFF2-40B4-BE49-F238E27FC236}">
+                    <a16:creationId xmlns:a16="http://schemas.microsoft.com/office/drawing/2014/main" id="{A75FBE51-9B4A-CC80-B56D-C17AF5BA0360}"/>
+                  </a:ext>
+                </a:extLst>
+              </p:cNvPr>
+              <p:cNvSpPr/>
+              <p:nvPr/>
+            </p:nvSpPr>
+            <p:spPr>
+              <a:xfrm>
+                <a:off x="1752216" y="10092420"/>
+                <a:ext cx="241195" cy="4206240"/>
+              </a:xfrm>
+              <a:prstGeom prst="rect">
+                <a:avLst/>
+              </a:prstGeom>
+              <a:solidFill>
+                <a:srgbClr val="E65100"/>
+              </a:solidFill>
+              <a:ln>
+                <a:noFill/>
+              </a:ln>
+            </p:spPr>
+            <p:style>
+              <a:lnRef idx="1">
+                <a:schemeClr val="accent1"/>
+              </a:lnRef>
+              <a:fillRef idx="3">
+                <a:schemeClr val="accent1"/>
+              </a:fillRef>
+              <a:effectRef idx="2">
+                <a:schemeClr val="accent1"/>
+              </a:effectRef>
+              <a:fontRef idx="minor">
+                <a:schemeClr val="lt1"/>
+              </a:fontRef>
+            </p:style>
+            <p:txBody>
+              <a:bodyPr rtlCol="0" anchor="ctr"/>
+              <a:lstStyle/>
+              <a:p>
+                <a:pPr algn="ctr"/>
+                <a:endParaRPr/>
+              </a:p>
+            </p:txBody>
+          </p:sp>
+          <p:sp>
+            <p:nvSpPr>
+              <p:cNvPr id="55" name="Rounded Rectangle 1047">
+                <a:extLst>
+                  <a:ext uri="{FF2B5EF4-FFF2-40B4-BE49-F238E27FC236}">
+                    <a16:creationId xmlns:a16="http://schemas.microsoft.com/office/drawing/2014/main" id="{0FCCAD35-4D7E-4FD2-8FDE-FC6A73609DC5}"/>
+                  </a:ext>
+                </a:extLst>
+              </p:cNvPr>
+              <p:cNvSpPr/>
+              <p:nvPr/>
+            </p:nvSpPr>
+            <p:spPr>
+              <a:xfrm>
+                <a:off x="2462567" y="10277802"/>
+                <a:ext cx="900000" cy="900000"/>
+              </a:xfrm>
+              <a:prstGeom prst="roundRect">
+                <a:avLst>
+                  <a:gd name="adj" fmla="val 8000"/>
+                </a:avLst>
+              </a:prstGeom>
+              <a:solidFill>
+                <a:srgbClr val="E65100"/>
+              </a:solidFill>
+              <a:ln>
+                <a:noFill/>
+              </a:ln>
+            </p:spPr>
+            <p:style>
+              <a:lnRef idx="1">
+                <a:schemeClr val="accent1"/>
+              </a:lnRef>
+              <a:fillRef idx="3">
+                <a:schemeClr val="accent1"/>
+              </a:fillRef>
+              <a:effectRef idx="2">
+                <a:schemeClr val="accent1"/>
+              </a:effectRef>
+              <a:fontRef idx="minor">
+                <a:schemeClr val="lt1"/>
+              </a:fontRef>
+            </p:style>
+            <p:txBody>
+              <a:bodyPr rtlCol="0" anchor="ctr"/>
+              <a:lstStyle/>
+              <a:p>
+                <a:pPr algn="ctr"/>
+                <a:endParaRPr/>
+              </a:p>
+            </p:txBody>
+          </p:sp>
+          <p:sp>
+            <p:nvSpPr>
+              <p:cNvPr id="56" name="Diamond 1076">
+                <a:extLst>
+                  <a:ext uri="{FF2B5EF4-FFF2-40B4-BE49-F238E27FC236}">
+                    <a16:creationId xmlns:a16="http://schemas.microsoft.com/office/drawing/2014/main" id="{B7373C03-2DE1-BA98-9C5B-61C7D037A159}"/>
+                  </a:ext>
+                </a:extLst>
+              </p:cNvPr>
+              <p:cNvSpPr/>
+              <p:nvPr/>
+            </p:nvSpPr>
+            <p:spPr>
+              <a:xfrm>
+                <a:off x="18549703" y="10988532"/>
+                <a:ext cx="344564" cy="365760"/>
+              </a:xfrm>
+              <a:prstGeom prst="diamond">
+                <a:avLst/>
+              </a:prstGeom>
+              <a:solidFill>
+                <a:srgbClr val="FF7043"/>
+              </a:solidFill>
+              <a:ln>
+                <a:noFill/>
+              </a:ln>
+            </p:spPr>
+            <p:style>
+              <a:lnRef idx="1">
+                <a:schemeClr val="accent1"/>
+              </a:lnRef>
+              <a:fillRef idx="3">
+                <a:schemeClr val="accent1"/>
+              </a:fillRef>
+              <a:effectRef idx="2">
+                <a:schemeClr val="accent1"/>
+              </a:effectRef>
+              <a:fontRef idx="minor">
+                <a:schemeClr val="lt1"/>
+              </a:fontRef>
+            </p:style>
+            <p:txBody>
+              <a:bodyPr rtlCol="0" anchor="ctr"/>
+              <a:lstStyle/>
+              <a:p>
+                <a:pPr algn="ctr"/>
+                <a:endParaRPr/>
+              </a:p>
+            </p:txBody>
+          </p:sp>
+          <p:sp>
+            <p:nvSpPr>
+              <p:cNvPr id="57" name="Rounded Rectangle 1077">
+                <a:extLst>
+                  <a:ext uri="{FF2B5EF4-FFF2-40B4-BE49-F238E27FC236}">
+                    <a16:creationId xmlns:a16="http://schemas.microsoft.com/office/drawing/2014/main" id="{ACBBF7F2-E2DE-2938-28BA-E78E5CC2997F}"/>
+                  </a:ext>
+                </a:extLst>
+              </p:cNvPr>
+              <p:cNvSpPr/>
+              <p:nvPr/>
+            </p:nvSpPr>
+            <p:spPr>
+              <a:xfrm>
+                <a:off x="18618616" y="12085812"/>
+                <a:ext cx="223966" cy="237744"/>
+              </a:xfrm>
+              <a:prstGeom prst="roundRect">
+                <a:avLst/>
+              </a:prstGeom>
+              <a:solidFill>
+                <a:srgbClr val="FFCC80"/>
+              </a:solidFill>
+              <a:ln>
+                <a:noFill/>
+              </a:ln>
+            </p:spPr>
+            <p:style>
+              <a:lnRef idx="1">
+                <a:schemeClr val="accent1"/>
+              </a:lnRef>
+              <a:fillRef idx="3">
+                <a:schemeClr val="accent1"/>
+              </a:fillRef>
+              <a:effectRef idx="2">
+                <a:schemeClr val="accent1"/>
+              </a:effectRef>
+              <a:fontRef idx="minor">
+                <a:schemeClr val="lt1"/>
+              </a:fontRef>
+            </p:style>
+            <p:txBody>
+              <a:bodyPr rtlCol="0" anchor="ctr"/>
+              <a:lstStyle/>
+              <a:p>
+                <a:pPr algn="ctr"/>
+                <a:endParaRPr/>
+              </a:p>
+            </p:txBody>
+          </p:sp>
+          <p:sp>
+            <p:nvSpPr>
+              <p:cNvPr id="58" name="Rectangle 1078">
+                <a:extLst>
+                  <a:ext uri="{FF2B5EF4-FFF2-40B4-BE49-F238E27FC236}">
+                    <a16:creationId xmlns:a16="http://schemas.microsoft.com/office/drawing/2014/main" id="{6802B6FE-7D73-C0C5-4F1C-15A9D6F715F5}"/>
+                  </a:ext>
+                </a:extLst>
+              </p:cNvPr>
+              <p:cNvSpPr/>
+              <p:nvPr/>
+            </p:nvSpPr>
+            <p:spPr>
+              <a:xfrm>
+                <a:off x="18653072" y="13091652"/>
+                <a:ext cx="155054" cy="164592"/>
+              </a:xfrm>
+              <a:prstGeom prst="rect">
+                <a:avLst/>
+              </a:prstGeom>
+              <a:solidFill>
+                <a:srgbClr val="FFE0B2"/>
+              </a:solidFill>
+              <a:ln>
+                <a:noFill/>
+              </a:ln>
+            </p:spPr>
+            <p:style>
+              <a:lnRef idx="1">
+                <a:schemeClr val="accent1"/>
+              </a:lnRef>
+              <a:fillRef idx="3">
+                <a:schemeClr val="accent1"/>
+              </a:fillRef>
+              <a:effectRef idx="2">
+                <a:schemeClr val="accent1"/>
+              </a:effectRef>
+              <a:fontRef idx="minor">
+                <a:schemeClr val="lt1"/>
+              </a:fontRef>
+            </p:style>
+            <p:txBody>
+              <a:bodyPr rtlCol="0" anchor="ctr"/>
+              <a:lstStyle/>
+              <a:p>
+                <a:pPr algn="ctr"/>
+                <a:endParaRPr/>
+              </a:p>
+            </p:txBody>
+          </p:sp>
+        </p:grpSp>
+        <p:grpSp>
+          <p:nvGrpSpPr>
+            <p:cNvPr id="13" name="그룹 12">
               <a:extLst>
                 <a:ext uri="{FF2B5EF4-FFF2-40B4-BE49-F238E27FC236}">
-                  <a16:creationId xmlns:a16="http://schemas.microsoft.com/office/drawing/2014/main" id="{096DB128-EA52-0253-2F4B-1C992E3688E8}"/>
+                  <a16:creationId xmlns:a16="http://schemas.microsoft.com/office/drawing/2014/main" id="{1C89CAF0-B002-E2F4-8AC0-C8DD99029697}"/>
                 </a:ext>
               </a:extLst>
             </p:cNvPr>
-            <p:cNvSpPr txBox="1"/>
+            <p:cNvGrpSpPr/>
             <p:nvPr/>
-          </p:nvSpPr>
-          <p:spPr>
+          </p:nvGrpSpPr>
+          <p:grpSpPr>
             <a:xfrm>
-              <a:off x="2437287" y="11598304"/>
-              <a:ext cx="1006032" cy="831517"/>
+              <a:off x="2437269" y="10231872"/>
+              <a:ext cx="16406421" cy="3664880"/>
+              <a:chOff x="2437269" y="11596587"/>
+              <a:chExt cx="16406421" cy="3664880"/>
             </a:xfrm>
-            <a:prstGeom prst="rect">
-              <a:avLst/>
-            </a:prstGeom>
-            <a:noFill/>
-          </p:spPr>
-          <p:txBody>
-            <a:bodyPr wrap="none" rtlCol="0" anchor="ctr">
-              <a:spAutoFit/>
-            </a:bodyPr>
-            <a:lstStyle/>
-            <a:p>
-              <a:r>
-                <a:rPr lang="en-US" altLang="ko-KR" sz="4800" dirty="0">
+          </p:grpSpPr>
+          <p:sp>
+            <p:nvSpPr>
+              <p:cNvPr id="1030" name="TextBox 1029">
+                <a:extLst>
+                  <a:ext uri="{FF2B5EF4-FFF2-40B4-BE49-F238E27FC236}">
+                    <a16:creationId xmlns:a16="http://schemas.microsoft.com/office/drawing/2014/main" id="{13DF435A-D740-D33E-5AB2-C49EA72C4DB0}"/>
+                  </a:ext>
+                </a:extLst>
+              </p:cNvPr>
+              <p:cNvSpPr txBox="1"/>
+              <p:nvPr/>
+            </p:nvSpPr>
+            <p:spPr>
+              <a:xfrm>
+                <a:off x="2437287" y="12588447"/>
+                <a:ext cx="2916000" cy="769441"/>
+              </a:xfrm>
+              <a:prstGeom prst="rect">
+                <a:avLst/>
+              </a:prstGeom>
+              <a:noFill/>
+            </p:spPr>
+            <p:txBody>
+              <a:bodyPr wrap="none" lIns="72000" tIns="36000" rIns="72000" bIns="36000" rtlCol="0">
+                <a:noAutofit/>
+              </a:bodyPr>
+              <a:lstStyle/>
+              <a:p>
+                <a:r>
+                  <a:rPr lang="ko-KR" altLang="en-US" sz="4400" dirty="0">
+                    <a:solidFill>
+                      <a:schemeClr val="tx1">
+                        <a:lumMod val="85000"/>
+                        <a:lumOff val="15000"/>
+                      </a:schemeClr>
+                    </a:solidFill>
+                    <a:latin typeface="페이퍼로지 6 SemiBold" pitchFamily="2" charset="-127"/>
+                    <a:ea typeface="페이퍼로지 6 SemiBold" pitchFamily="2" charset="-127"/>
+                  </a:rPr>
+                  <a:t>배경 및 목적</a:t>
+                </a:r>
+              </a:p>
+            </p:txBody>
+          </p:sp>
+          <p:sp>
+            <p:nvSpPr>
+              <p:cNvPr id="1031" name="TextBox 1030">
+                <a:extLst>
+                  <a:ext uri="{FF2B5EF4-FFF2-40B4-BE49-F238E27FC236}">
+                    <a16:creationId xmlns:a16="http://schemas.microsoft.com/office/drawing/2014/main" id="{096DB128-EA52-0253-2F4B-1C992E3688E8}"/>
+                  </a:ext>
+                </a:extLst>
+              </p:cNvPr>
+              <p:cNvSpPr txBox="1"/>
+              <p:nvPr/>
+            </p:nvSpPr>
+            <p:spPr>
+              <a:xfrm>
+                <a:off x="2437269" y="11596587"/>
+                <a:ext cx="1006032" cy="831517"/>
+              </a:xfrm>
+              <a:prstGeom prst="rect">
+                <a:avLst/>
+              </a:prstGeom>
+              <a:noFill/>
+            </p:spPr>
+            <p:txBody>
+              <a:bodyPr wrap="none" rtlCol="0" anchor="ctr">
+                <a:spAutoFit/>
+              </a:bodyPr>
+              <a:lstStyle/>
+              <a:p>
+                <a:r>
+                  <a:rPr lang="en-US" altLang="ko-KR" sz="4800" dirty="0">
+                    <a:solidFill>
+                      <a:schemeClr val="accent2"/>
+                    </a:solidFill>
+                    <a:latin typeface="페이퍼로지 8 ExtraBold" pitchFamily="2" charset="-127"/>
+                    <a:ea typeface="페이퍼로지 8 ExtraBold" pitchFamily="2" charset="-127"/>
+                  </a:rPr>
+                  <a:t>02</a:t>
+                </a:r>
+                <a:endParaRPr lang="ko-KR" altLang="en-US" sz="4800" dirty="0">
                   <a:solidFill>
                     <a:schemeClr val="accent2"/>
                   </a:solidFill>
                   <a:latin typeface="페이퍼로지 8 ExtraBold" pitchFamily="2" charset="-127"/>
                   <a:ea typeface="페이퍼로지 8 ExtraBold" pitchFamily="2" charset="-127"/>
-                </a:rPr>
-                <a:t>02</a:t>
-              </a:r>
-              <a:endParaRPr lang="ko-KR" altLang="en-US" sz="4800" dirty="0">
+                </a:endParaRPr>
+              </a:p>
+            </p:txBody>
+          </p:sp>
+          <p:sp>
+            <p:nvSpPr>
+              <p:cNvPr id="1025" name="TextBox 1024">
+                <a:extLst>
+                  <a:ext uri="{FF2B5EF4-FFF2-40B4-BE49-F238E27FC236}">
+                    <a16:creationId xmlns:a16="http://schemas.microsoft.com/office/drawing/2014/main" id="{219E9826-9038-8A1C-E272-2CE26AAC3236}"/>
+                  </a:ext>
+                </a:extLst>
+              </p:cNvPr>
+              <p:cNvSpPr txBox="1"/>
+              <p:nvPr/>
+            </p:nvSpPr>
+            <p:spPr>
+              <a:xfrm>
+                <a:off x="6031031" y="11667829"/>
+                <a:ext cx="12812659" cy="3593638"/>
+              </a:xfrm>
+              <a:prstGeom prst="rect">
+                <a:avLst/>
+              </a:prstGeom>
+              <a:noFill/>
+            </p:spPr>
+            <p:txBody>
+              <a:bodyPr wrap="square" lIns="72000" tIns="36000" rIns="72000" bIns="36000" rtlCol="0" anchor="t">
+                <a:normAutofit/>
+              </a:bodyPr>
+              <a:lstStyle/>
+              <a:p>
+                <a:pPr marL="720000" marR="0" lvl="0" indent="-720000" algn="l" defTabSz="2159996" rtl="0" eaLnBrk="1" fontAlgn="auto" latinLnBrk="1" hangingPunct="1">
+                  <a:spcAft>
+                    <a:spcPts val="1200"/>
+                  </a:spcAft>
+                  <a:buClr>
+                    <a:schemeClr val="accent2"/>
+                  </a:buClr>
+                  <a:buSzTx/>
+                  <a:buFont typeface="프리젠테이션 4 Regular" pitchFamily="2" charset="-127"/>
+                  <a:buChar char=""/>
+                </a:pPr>
+                <a:r>
+                  <a:rPr lang="ko-KR" altLang="en-US" sz="4000" dirty="0">
+                    <a:solidFill>
+                      <a:schemeClr val="tx1">
+                        <a:lumMod val="95000"/>
+                        <a:lumOff val="5000"/>
+                      </a:schemeClr>
+                    </a:solidFill>
+                  </a:rPr>
+                  <a:t>기존 문제은행 사이트는 단순 출제에 그쳐 집중력 유지가 어려움</a:t>
+                </a:r>
+              </a:p>
+              <a:p>
+                <a:pPr marL="720000" marR="0" lvl="0" indent="-720000" algn="l" defTabSz="2159996" rtl="0" eaLnBrk="1" fontAlgn="auto" latinLnBrk="1" hangingPunct="1">
+                  <a:spcAft>
+                    <a:spcPts val="1200"/>
+                  </a:spcAft>
+                  <a:buClr>
+                    <a:schemeClr val="accent2"/>
+                  </a:buClr>
+                  <a:buSzTx/>
+                  <a:buFont typeface="프리젠테이션 4 Regular" pitchFamily="2" charset="-127"/>
+                  <a:buChar char=""/>
+                </a:pPr>
+                <a:r>
+                  <a:rPr lang="ko-KR" altLang="en-US" sz="4000" dirty="0">
+                    <a:solidFill>
+                      <a:schemeClr val="tx1">
+                        <a:lumMod val="95000"/>
+                        <a:lumOff val="5000"/>
+                      </a:schemeClr>
+                    </a:solidFill>
+                  </a:rPr>
+                  <a:t>반복 풀이만으로는 암기에 의존하게 되는 한계 존재</a:t>
+                </a:r>
+              </a:p>
+              <a:p>
+                <a:pPr marL="720000" marR="0" lvl="0" indent="-720000" algn="l" defTabSz="2159996" rtl="0" eaLnBrk="1" fontAlgn="auto" latinLnBrk="1" hangingPunct="1">
+                  <a:spcAft>
+                    <a:spcPts val="1200"/>
+                  </a:spcAft>
+                  <a:buClr>
+                    <a:schemeClr val="accent2"/>
+                  </a:buClr>
+                  <a:buSzTx/>
+                  <a:buFont typeface="프리젠테이션 4 Regular" pitchFamily="2" charset="-127"/>
+                  <a:buChar char=""/>
+                </a:pPr>
+                <a:r>
+                  <a:rPr lang="ko-KR" altLang="en-US" sz="4000" dirty="0">
+                    <a:solidFill>
+                      <a:schemeClr val="tx1">
+                        <a:lumMod val="95000"/>
+                        <a:lumOff val="5000"/>
+                      </a:schemeClr>
+                    </a:solidFill>
+                  </a:rPr>
+                  <a:t>게임 요소를 접목해 재미와 학습 효율을 동시에 향상</a:t>
+                </a:r>
+              </a:p>
+              <a:p>
+                <a:pPr marL="720000" marR="0" lvl="0" indent="-720000" algn="l" defTabSz="2159996" rtl="0" eaLnBrk="1" fontAlgn="auto" latinLnBrk="1" hangingPunct="1">
+                  <a:spcAft>
+                    <a:spcPts val="1200"/>
+                  </a:spcAft>
+                  <a:buClr>
+                    <a:schemeClr val="accent2"/>
+                  </a:buClr>
+                  <a:buSzTx/>
+                  <a:buFont typeface="프리젠테이션 4 Regular" pitchFamily="2" charset="-127"/>
+                  <a:buChar char=""/>
+                </a:pPr>
+                <a:r>
+                  <a:rPr lang="ko-KR" altLang="en-US" sz="4000" dirty="0">
+                    <a:solidFill>
+                      <a:schemeClr val="tx1">
+                        <a:lumMod val="95000"/>
+                        <a:lumOff val="5000"/>
+                      </a:schemeClr>
+                    </a:solidFill>
+                  </a:rPr>
+                  <a:t>누구나 원하는 과목의 문제를 추가해 활용 가능한 범용 학습 프로그램 제작</a:t>
+                </a:r>
+              </a:p>
+            </p:txBody>
+          </p:sp>
+          <p:cxnSp>
+            <p:nvCxnSpPr>
+              <p:cNvPr id="1029" name="직선 연결선 1028">
+                <a:extLst>
+                  <a:ext uri="{FF2B5EF4-FFF2-40B4-BE49-F238E27FC236}">
+                    <a16:creationId xmlns:a16="http://schemas.microsoft.com/office/drawing/2014/main" id="{31A4068E-D7DB-612A-DEC3-94E0F1F5C53A}"/>
+                  </a:ext>
+                </a:extLst>
+              </p:cNvPr>
+              <p:cNvCxnSpPr>
+                <a:cxnSpLocks/>
+              </p:cNvCxnSpPr>
+              <p:nvPr/>
+            </p:nvCxnSpPr>
+            <p:spPr>
+              <a:xfrm>
+                <a:off x="3923539" y="12014062"/>
+                <a:ext cx="2004816" cy="0"/>
+              </a:xfrm>
+              <a:prstGeom prst="line">
+                <a:avLst/>
+              </a:prstGeom>
+              <a:ln w="47625" cap="rnd">
                 <a:solidFill>
-                  <a:schemeClr val="accent2"/>
+                  <a:schemeClr val="tx2">
+                    <a:lumMod val="40000"/>
+                    <a:lumOff val="60000"/>
+                  </a:schemeClr>
                 </a:solidFill>
-                <a:latin typeface="페이퍼로지 8 ExtraBold" pitchFamily="2" charset="-127"/>
-                <a:ea typeface="페이퍼로지 8 ExtraBold" pitchFamily="2" charset="-127"/>
-              </a:endParaRPr>
-            </a:p>
-          </p:txBody>
-        </p:sp>
-        <p:sp>
-          <p:nvSpPr>
-            <p:cNvPr id="1025" name="TextBox 1024">
-              <a:extLst>
-                <a:ext uri="{FF2B5EF4-FFF2-40B4-BE49-F238E27FC236}">
-                  <a16:creationId xmlns:a16="http://schemas.microsoft.com/office/drawing/2014/main" id="{219E9826-9038-8A1C-E272-2CE26AAC3236}"/>
-                </a:ext>
-              </a:extLst>
-            </p:cNvPr>
-            <p:cNvSpPr txBox="1"/>
-            <p:nvPr/>
-          </p:nvSpPr>
-          <p:spPr>
-            <a:xfrm>
-              <a:off x="6408575" y="11667829"/>
-              <a:ext cx="12812659" cy="3593638"/>
-            </a:xfrm>
-            <a:prstGeom prst="rect">
-              <a:avLst/>
-            </a:prstGeom>
-            <a:noFill/>
-          </p:spPr>
-          <p:txBody>
-            <a:bodyPr wrap="square" lIns="72000" tIns="36000" rIns="72000" bIns="36000" rtlCol="0" anchor="t">
-              <a:normAutofit/>
-            </a:bodyPr>
-            <a:lstStyle/>
-            <a:p>
-              <a:pPr marL="720000" marR="0" lvl="0" indent="-720000" algn="l" defTabSz="2159996" rtl="0" eaLnBrk="1" fontAlgn="auto" latinLnBrk="1" hangingPunct="1">
-                <a:spcAft>
-                  <a:spcPts val="1200"/>
-                </a:spcAft>
-                <a:buClr>
-                  <a:schemeClr val="accent2"/>
-                </a:buClr>
-                <a:buSzTx/>
-                <a:buFont typeface="프리젠테이션 4 Regular" pitchFamily="2" charset="-127"/>
-                <a:buChar char=""/>
-              </a:pPr>
-              <a:r>
-                <a:rPr lang="ko-KR" altLang="en-US" sz="4000" dirty="0">
-                  <a:solidFill>
-                    <a:schemeClr val="tx1">
-                      <a:lumMod val="95000"/>
-                      <a:lumOff val="5000"/>
-                    </a:schemeClr>
-                  </a:solidFill>
-                </a:rPr>
-                <a:t>기존 문제은행 사이트는 단순 출제에 그쳐 집중력 유지가 어려움</a:t>
-              </a:r>
-            </a:p>
-            <a:p>
-              <a:pPr marL="720000" marR="0" lvl="0" indent="-720000" algn="l" defTabSz="2159996" rtl="0" eaLnBrk="1" fontAlgn="auto" latinLnBrk="1" hangingPunct="1">
-                <a:spcAft>
-                  <a:spcPts val="1200"/>
-                </a:spcAft>
-                <a:buClr>
-                  <a:schemeClr val="accent2"/>
-                </a:buClr>
-                <a:buSzTx/>
-                <a:buFont typeface="프리젠테이션 4 Regular" pitchFamily="2" charset="-127"/>
-                <a:buChar char=""/>
-              </a:pPr>
-              <a:r>
-                <a:rPr lang="ko-KR" altLang="en-US" sz="4000" dirty="0">
-                  <a:solidFill>
-                    <a:schemeClr val="tx1">
-                      <a:lumMod val="95000"/>
-                      <a:lumOff val="5000"/>
-                    </a:schemeClr>
-                  </a:solidFill>
-                </a:rPr>
-                <a:t>반복 풀이만으로는 암기에 의존하게 되는 한계 존재</a:t>
-              </a:r>
-            </a:p>
-            <a:p>
-              <a:pPr marL="720000" marR="0" lvl="0" indent="-720000" algn="l" defTabSz="2159996" rtl="0" eaLnBrk="1" fontAlgn="auto" latinLnBrk="1" hangingPunct="1">
-                <a:spcAft>
-                  <a:spcPts val="1200"/>
-                </a:spcAft>
-                <a:buClr>
-                  <a:schemeClr val="accent2"/>
-                </a:buClr>
-                <a:buSzTx/>
-                <a:buFont typeface="프리젠테이션 4 Regular" pitchFamily="2" charset="-127"/>
-                <a:buChar char=""/>
-              </a:pPr>
-              <a:r>
-                <a:rPr lang="ko-KR" altLang="en-US" sz="4000" dirty="0">
-                  <a:solidFill>
-                    <a:schemeClr val="tx1">
-                      <a:lumMod val="95000"/>
-                      <a:lumOff val="5000"/>
-                    </a:schemeClr>
-                  </a:solidFill>
-                </a:rPr>
-                <a:t>게임 요소를 접목해 재미와 학습 효율을 동시에 향상</a:t>
-              </a:r>
-            </a:p>
-            <a:p>
-              <a:pPr marL="720000" marR="0" lvl="0" indent="-720000" algn="l" defTabSz="2159996" rtl="0" eaLnBrk="1" fontAlgn="auto" latinLnBrk="1" hangingPunct="1">
-                <a:spcAft>
-                  <a:spcPts val="1200"/>
-                </a:spcAft>
-                <a:buClr>
-                  <a:schemeClr val="accent2"/>
-                </a:buClr>
-                <a:buSzTx/>
-                <a:buFont typeface="프리젠테이션 4 Regular" pitchFamily="2" charset="-127"/>
-                <a:buChar char=""/>
-              </a:pPr>
-              <a:r>
-                <a:rPr lang="ko-KR" altLang="en-US" sz="4000" dirty="0">
-                  <a:solidFill>
-                    <a:schemeClr val="tx1">
-                      <a:lumMod val="95000"/>
-                      <a:lumOff val="5000"/>
-                    </a:schemeClr>
-                  </a:solidFill>
-                </a:rPr>
-                <a:t>누구나 원하는 과목의 문제를 추가해 활용 가능한 범용 학습 프로그램 제작</a:t>
-              </a:r>
-            </a:p>
-          </p:txBody>
-        </p:sp>
-        <p:cxnSp>
-          <p:nvCxnSpPr>
-            <p:cNvPr id="1029" name="직선 연결선 1028">
-              <a:extLst>
-                <a:ext uri="{FF2B5EF4-FFF2-40B4-BE49-F238E27FC236}">
-                  <a16:creationId xmlns:a16="http://schemas.microsoft.com/office/drawing/2014/main" id="{31A4068E-D7DB-612A-DEC3-94E0F1F5C53A}"/>
-                </a:ext>
-              </a:extLst>
-            </p:cNvPr>
-            <p:cNvCxnSpPr>
-              <a:cxnSpLocks/>
-            </p:cNvCxnSpPr>
-            <p:nvPr/>
-          </p:nvCxnSpPr>
-          <p:spPr>
-            <a:xfrm>
-              <a:off x="3923539" y="12014062"/>
-              <a:ext cx="2004816" cy="0"/>
-            </a:xfrm>
-            <a:prstGeom prst="line">
-              <a:avLst/>
-            </a:prstGeom>
-            <a:ln w="47625" cap="rnd">
-              <a:solidFill>
-                <a:schemeClr val="tx2">
-                  <a:lumMod val="40000"/>
-                  <a:lumOff val="60000"/>
-                </a:schemeClr>
-              </a:solidFill>
-              <a:prstDash val="sysDot"/>
-              <a:round/>
-            </a:ln>
-          </p:spPr>
-          <p:style>
-            <a:lnRef idx="1">
-              <a:schemeClr val="accent1"/>
-            </a:lnRef>
-            <a:fillRef idx="0">
-              <a:schemeClr val="accent1"/>
-            </a:fillRef>
-            <a:effectRef idx="0">
-              <a:schemeClr val="accent1"/>
-            </a:effectRef>
-            <a:fontRef idx="minor">
-              <a:schemeClr val="tx1"/>
-            </a:fontRef>
-          </p:style>
-        </p:cxnSp>
+                <a:prstDash val="sysDot"/>
+                <a:round/>
+              </a:ln>
+            </p:spPr>
+            <p:style>
+              <a:lnRef idx="1">
+                <a:schemeClr val="accent1"/>
+              </a:lnRef>
+              <a:fillRef idx="0">
+                <a:schemeClr val="accent1"/>
+              </a:fillRef>
+              <a:effectRef idx="0">
+                <a:schemeClr val="accent1"/>
+              </a:effectRef>
+              <a:fontRef idx="minor">
+                <a:schemeClr val="tx1"/>
+              </a:fontRef>
+            </p:style>
+          </p:cxnSp>
+        </p:grpSp>
       </p:grpSp>
       <p:grpSp>
         <p:nvGrpSpPr>
-          <p:cNvPr id="12" name="그룹 11">
+          <p:cNvPr id="64" name="그룹 63">
             <a:extLst>
               <a:ext uri="{FF2B5EF4-FFF2-40B4-BE49-F238E27FC236}">
-                <a16:creationId xmlns:a16="http://schemas.microsoft.com/office/drawing/2014/main" id="{1A3BB66E-CCA3-A88B-5FE1-3142613BB8A3}"/>
+                <a16:creationId xmlns:a16="http://schemas.microsoft.com/office/drawing/2014/main" id="{C3A7BC45-FC6F-7124-3DC0-6599F209DB87}"/>
               </a:ext>
             </a:extLst>
           </p:cNvPr>
@@ -27251,304 +27939,648 @@
         </p:nvGrpSpPr>
         <p:grpSpPr>
           <a:xfrm>
-            <a:off x="2437269" y="14399444"/>
-            <a:ext cx="16783965" cy="5256583"/>
-            <a:chOff x="2437269" y="16064860"/>
-            <a:chExt cx="16783965" cy="5256583"/>
+            <a:off x="1510729" y="13679364"/>
+            <a:ext cx="18531245" cy="5589797"/>
+            <a:chOff x="1752216" y="14234651"/>
+            <a:chExt cx="17760514" cy="5589797"/>
           </a:xfrm>
         </p:grpSpPr>
-        <p:sp>
-          <p:nvSpPr>
-            <p:cNvPr id="1037" name="TextBox 1036">
+        <p:grpSp>
+          <p:nvGrpSpPr>
+            <p:cNvPr id="61" name="그룹 60">
               <a:extLst>
                 <a:ext uri="{FF2B5EF4-FFF2-40B4-BE49-F238E27FC236}">
-                  <a16:creationId xmlns:a16="http://schemas.microsoft.com/office/drawing/2014/main" id="{DCCEC274-F563-E0BB-8BA3-34200345136B}"/>
+                  <a16:creationId xmlns:a16="http://schemas.microsoft.com/office/drawing/2014/main" id="{F4305278-77F3-21DE-7B62-C801A59F19FF}"/>
                 </a:ext>
               </a:extLst>
             </p:cNvPr>
-            <p:cNvSpPr txBox="1"/>
+            <p:cNvGrpSpPr/>
             <p:nvPr/>
-          </p:nvSpPr>
-          <p:spPr>
+          </p:nvGrpSpPr>
+          <p:grpSpPr>
             <a:xfrm>
-              <a:off x="2437269" y="17055003"/>
-              <a:ext cx="2916000" cy="769441"/>
+              <a:off x="1752216" y="14234651"/>
+              <a:ext cx="17760514" cy="5589797"/>
+              <a:chOff x="1752216" y="14234652"/>
+              <a:chExt cx="17400474" cy="5715000"/>
             </a:xfrm>
-            <a:prstGeom prst="rect">
-              <a:avLst/>
-            </a:prstGeom>
-            <a:noFill/>
-          </p:spPr>
-          <p:txBody>
-            <a:bodyPr wrap="none" lIns="72000" tIns="36000" rIns="72000" bIns="36000" rtlCol="0">
-              <a:noAutofit/>
-            </a:bodyPr>
-            <a:lstStyle/>
-            <a:p>
-              <a:r>
-                <a:rPr lang="ko-KR" altLang="en-US" sz="4400" dirty="0">
-                  <a:solidFill>
-                    <a:schemeClr val="tx1">
-                      <a:lumMod val="85000"/>
-                      <a:lumOff val="15000"/>
-                    </a:schemeClr>
-                  </a:solidFill>
-                  <a:latin typeface="페이퍼로지 6 SemiBold" pitchFamily="2" charset="-127"/>
-                  <a:ea typeface="페이퍼로지 6 SemiBold" pitchFamily="2" charset="-127"/>
-                </a:rPr>
-                <a:t>내용</a:t>
-              </a:r>
-            </a:p>
-          </p:txBody>
-        </p:sp>
-        <p:sp>
-          <p:nvSpPr>
-            <p:cNvPr id="1038" name="TextBox 1037">
+          </p:grpSpPr>
+          <p:sp>
+            <p:nvSpPr>
+              <p:cNvPr id="42" name="Rectangle 1042">
+                <a:extLst>
+                  <a:ext uri="{FF2B5EF4-FFF2-40B4-BE49-F238E27FC236}">
+                    <a16:creationId xmlns:a16="http://schemas.microsoft.com/office/drawing/2014/main" id="{70592B72-EE6B-A43D-2325-66A1B1B90086}"/>
+                  </a:ext>
+                </a:extLst>
+              </p:cNvPr>
+              <p:cNvSpPr/>
+              <p:nvPr/>
+            </p:nvSpPr>
+            <p:spPr>
+              <a:xfrm>
+                <a:off x="1752216" y="14234652"/>
+                <a:ext cx="17400474" cy="5715000"/>
+              </a:xfrm>
+              <a:prstGeom prst="rect">
+                <a:avLst/>
+              </a:prstGeom>
+              <a:solidFill>
+                <a:srgbClr val="E8F5E9"/>
+              </a:solidFill>
+              <a:ln w="19050">
+                <a:noFill/>
+              </a:ln>
+            </p:spPr>
+            <p:style>
+              <a:lnRef idx="1">
+                <a:schemeClr val="accent1"/>
+              </a:lnRef>
+              <a:fillRef idx="3">
+                <a:schemeClr val="accent1"/>
+              </a:fillRef>
+              <a:effectRef idx="2">
+                <a:schemeClr val="accent1"/>
+              </a:effectRef>
+              <a:fontRef idx="minor">
+                <a:schemeClr val="lt1"/>
+              </a:fontRef>
+            </p:style>
+            <p:txBody>
+              <a:bodyPr rtlCol="0" anchor="ctr"/>
+              <a:lstStyle/>
+              <a:p>
+                <a:pPr algn="ctr"/>
+                <a:endParaRPr/>
+              </a:p>
+            </p:txBody>
+          </p:sp>
+          <p:sp>
+            <p:nvSpPr>
+              <p:cNvPr id="43" name="Rectangle 1043">
+                <a:extLst>
+                  <a:ext uri="{FF2B5EF4-FFF2-40B4-BE49-F238E27FC236}">
+                    <a16:creationId xmlns:a16="http://schemas.microsoft.com/office/drawing/2014/main" id="{4EC599AB-C4BB-8AC0-BC44-8784D037212E}"/>
+                  </a:ext>
+                </a:extLst>
+              </p:cNvPr>
+              <p:cNvSpPr/>
+              <p:nvPr/>
+            </p:nvSpPr>
+            <p:spPr>
+              <a:xfrm>
+                <a:off x="1752216" y="14234652"/>
+                <a:ext cx="241195" cy="5715000"/>
+              </a:xfrm>
+              <a:prstGeom prst="rect">
+                <a:avLst/>
+              </a:prstGeom>
+              <a:solidFill>
+                <a:srgbClr val="1B5E20"/>
+              </a:solidFill>
+              <a:ln>
+                <a:noFill/>
+              </a:ln>
+            </p:spPr>
+            <p:style>
+              <a:lnRef idx="1">
+                <a:schemeClr val="accent1"/>
+              </a:lnRef>
+              <a:fillRef idx="3">
+                <a:schemeClr val="accent1"/>
+              </a:fillRef>
+              <a:effectRef idx="2">
+                <a:schemeClr val="accent1"/>
+              </a:effectRef>
+              <a:fontRef idx="minor">
+                <a:schemeClr val="lt1"/>
+              </a:fontRef>
+            </p:style>
+            <p:txBody>
+              <a:bodyPr rtlCol="0" anchor="ctr"/>
+              <a:lstStyle/>
+              <a:p>
+                <a:pPr algn="ctr"/>
+                <a:endParaRPr/>
+              </a:p>
+            </p:txBody>
+          </p:sp>
+          <p:sp>
+            <p:nvSpPr>
+              <p:cNvPr id="44" name="Rounded Rectangle 1048">
+                <a:extLst>
+                  <a:ext uri="{FF2B5EF4-FFF2-40B4-BE49-F238E27FC236}">
+                    <a16:creationId xmlns:a16="http://schemas.microsoft.com/office/drawing/2014/main" id="{D00B2C3D-A017-34E6-9C70-C7B309DDA4C1}"/>
+                  </a:ext>
+                </a:extLst>
+              </p:cNvPr>
+              <p:cNvSpPr/>
+              <p:nvPr/>
+            </p:nvSpPr>
+            <p:spPr>
+              <a:xfrm>
+                <a:off x="2462567" y="14447466"/>
+                <a:ext cx="900000" cy="900000"/>
+              </a:xfrm>
+              <a:prstGeom prst="roundRect">
+                <a:avLst>
+                  <a:gd name="adj" fmla="val 8000"/>
+                </a:avLst>
+              </a:prstGeom>
+              <a:solidFill>
+                <a:srgbClr val="1B5E20"/>
+              </a:solidFill>
+              <a:ln>
+                <a:noFill/>
+              </a:ln>
+            </p:spPr>
+            <p:style>
+              <a:lnRef idx="1">
+                <a:schemeClr val="accent1"/>
+              </a:lnRef>
+              <a:fillRef idx="3">
+                <a:schemeClr val="accent1"/>
+              </a:fillRef>
+              <a:effectRef idx="2">
+                <a:schemeClr val="accent1"/>
+              </a:effectRef>
+              <a:fontRef idx="minor">
+                <a:schemeClr val="lt1"/>
+              </a:fontRef>
+            </p:style>
+            <p:txBody>
+              <a:bodyPr rtlCol="0" anchor="ctr"/>
+              <a:lstStyle/>
+              <a:p>
+                <a:pPr algn="ctr"/>
+                <a:endParaRPr/>
+              </a:p>
+            </p:txBody>
+          </p:sp>
+          <p:sp>
+            <p:nvSpPr>
+              <p:cNvPr id="39" name="Diamond 1079">
+                <a:extLst>
+                  <a:ext uri="{FF2B5EF4-FFF2-40B4-BE49-F238E27FC236}">
+                    <a16:creationId xmlns:a16="http://schemas.microsoft.com/office/drawing/2014/main" id="{8D39BA49-84B4-A402-EEE2-C986FDDA29EB}"/>
+                  </a:ext>
+                </a:extLst>
+              </p:cNvPr>
+              <p:cNvSpPr/>
+              <p:nvPr/>
+            </p:nvSpPr>
+            <p:spPr>
+              <a:xfrm>
+                <a:off x="18549703" y="15743412"/>
+                <a:ext cx="344564" cy="365760"/>
+              </a:xfrm>
+              <a:prstGeom prst="diamond">
+                <a:avLst/>
+              </a:prstGeom>
+              <a:solidFill>
+                <a:srgbClr val="66BB6A"/>
+              </a:solidFill>
+              <a:ln>
+                <a:noFill/>
+              </a:ln>
+            </p:spPr>
+            <p:style>
+              <a:lnRef idx="1">
+                <a:schemeClr val="accent1"/>
+              </a:lnRef>
+              <a:fillRef idx="3">
+                <a:schemeClr val="accent1"/>
+              </a:fillRef>
+              <a:effectRef idx="2">
+                <a:schemeClr val="accent1"/>
+              </a:effectRef>
+              <a:fontRef idx="minor">
+                <a:schemeClr val="lt1"/>
+              </a:fontRef>
+            </p:style>
+            <p:txBody>
+              <a:bodyPr rtlCol="0" anchor="ctr"/>
+              <a:lstStyle/>
+              <a:p>
+                <a:pPr algn="ctr"/>
+                <a:endParaRPr/>
+              </a:p>
+            </p:txBody>
+          </p:sp>
+          <p:sp>
+            <p:nvSpPr>
+              <p:cNvPr id="40" name="Rounded Rectangle 1080">
+                <a:extLst>
+                  <a:ext uri="{FF2B5EF4-FFF2-40B4-BE49-F238E27FC236}">
+                    <a16:creationId xmlns:a16="http://schemas.microsoft.com/office/drawing/2014/main" id="{28FD21B9-7018-DC1A-FF0C-2509F3E1B27B}"/>
+                  </a:ext>
+                </a:extLst>
+              </p:cNvPr>
+              <p:cNvSpPr/>
+              <p:nvPr/>
+            </p:nvSpPr>
+            <p:spPr>
+              <a:xfrm>
+                <a:off x="18618616" y="17023572"/>
+                <a:ext cx="223966" cy="237744"/>
+              </a:xfrm>
+              <a:prstGeom prst="roundRect">
+                <a:avLst/>
+              </a:prstGeom>
+              <a:solidFill>
+                <a:srgbClr val="A5D6A7"/>
+              </a:solidFill>
+              <a:ln>
+                <a:noFill/>
+              </a:ln>
+            </p:spPr>
+            <p:style>
+              <a:lnRef idx="1">
+                <a:schemeClr val="accent1"/>
+              </a:lnRef>
+              <a:fillRef idx="3">
+                <a:schemeClr val="accent1"/>
+              </a:fillRef>
+              <a:effectRef idx="2">
+                <a:schemeClr val="accent1"/>
+              </a:effectRef>
+              <a:fontRef idx="minor">
+                <a:schemeClr val="lt1"/>
+              </a:fontRef>
+            </p:style>
+            <p:txBody>
+              <a:bodyPr rtlCol="0" anchor="ctr"/>
+              <a:lstStyle/>
+              <a:p>
+                <a:pPr algn="ctr"/>
+                <a:endParaRPr/>
+              </a:p>
+            </p:txBody>
+          </p:sp>
+          <p:sp>
+            <p:nvSpPr>
+              <p:cNvPr id="41" name="Rectangle 1081">
+                <a:extLst>
+                  <a:ext uri="{FF2B5EF4-FFF2-40B4-BE49-F238E27FC236}">
+                    <a16:creationId xmlns:a16="http://schemas.microsoft.com/office/drawing/2014/main" id="{FA71C07E-618B-4BCE-194C-D0F80B28F038}"/>
+                  </a:ext>
+                </a:extLst>
+              </p:cNvPr>
+              <p:cNvSpPr/>
+              <p:nvPr/>
+            </p:nvSpPr>
+            <p:spPr>
+              <a:xfrm>
+                <a:off x="18653072" y="18212292"/>
+                <a:ext cx="155054" cy="164592"/>
+              </a:xfrm>
+              <a:prstGeom prst="rect">
+                <a:avLst/>
+              </a:prstGeom>
+              <a:solidFill>
+                <a:srgbClr val="C8E6C9"/>
+              </a:solidFill>
+              <a:ln>
+                <a:noFill/>
+              </a:ln>
+            </p:spPr>
+            <p:style>
+              <a:lnRef idx="1">
+                <a:schemeClr val="accent1"/>
+              </a:lnRef>
+              <a:fillRef idx="3">
+                <a:schemeClr val="accent1"/>
+              </a:fillRef>
+              <a:effectRef idx="2">
+                <a:schemeClr val="accent1"/>
+              </a:effectRef>
+              <a:fontRef idx="minor">
+                <a:schemeClr val="lt1"/>
+              </a:fontRef>
+            </p:style>
+            <p:txBody>
+              <a:bodyPr rtlCol="0" anchor="ctr"/>
+              <a:lstStyle/>
+              <a:p>
+                <a:pPr algn="ctr"/>
+                <a:endParaRPr/>
+              </a:p>
+            </p:txBody>
+          </p:sp>
+        </p:grpSp>
+        <p:grpSp>
+          <p:nvGrpSpPr>
+            <p:cNvPr id="12" name="그룹 11">
               <a:extLst>
                 <a:ext uri="{FF2B5EF4-FFF2-40B4-BE49-F238E27FC236}">
-                  <a16:creationId xmlns:a16="http://schemas.microsoft.com/office/drawing/2014/main" id="{7503E29B-D0E0-0503-67B1-56CF4DFF6690}"/>
+                  <a16:creationId xmlns:a16="http://schemas.microsoft.com/office/drawing/2014/main" id="{1A3BB66E-CCA3-A88B-5FE1-3142613BB8A3}"/>
                 </a:ext>
               </a:extLst>
             </p:cNvPr>
-            <p:cNvSpPr txBox="1"/>
+            <p:cNvGrpSpPr/>
             <p:nvPr/>
-          </p:nvSpPr>
-          <p:spPr>
+          </p:nvGrpSpPr>
+          <p:grpSpPr>
             <a:xfrm>
-              <a:off x="2437269" y="16064860"/>
-              <a:ext cx="1006031" cy="831516"/>
+              <a:off x="2422475" y="14415470"/>
+              <a:ext cx="16421215" cy="5240557"/>
+              <a:chOff x="2422475" y="16080886"/>
+              <a:chExt cx="16421215" cy="5240557"/>
             </a:xfrm>
-            <a:prstGeom prst="rect">
-              <a:avLst/>
-            </a:prstGeom>
-            <a:noFill/>
-          </p:spPr>
-          <p:txBody>
-            <a:bodyPr wrap="none" rtlCol="0" anchor="ctr">
-              <a:spAutoFit/>
-            </a:bodyPr>
-            <a:lstStyle/>
-            <a:p>
-              <a:r>
-                <a:rPr lang="en-US" altLang="ko-KR" sz="4800" dirty="0">
+          </p:grpSpPr>
+          <p:sp>
+            <p:nvSpPr>
+              <p:cNvPr id="1037" name="TextBox 1036">
+                <a:extLst>
+                  <a:ext uri="{FF2B5EF4-FFF2-40B4-BE49-F238E27FC236}">
+                    <a16:creationId xmlns:a16="http://schemas.microsoft.com/office/drawing/2014/main" id="{DCCEC274-F563-E0BB-8BA3-34200345136B}"/>
+                  </a:ext>
+                </a:extLst>
+              </p:cNvPr>
+              <p:cNvSpPr txBox="1"/>
+              <p:nvPr/>
+            </p:nvSpPr>
+            <p:spPr>
+              <a:xfrm>
+                <a:off x="2437269" y="17055003"/>
+                <a:ext cx="2916000" cy="769441"/>
+              </a:xfrm>
+              <a:prstGeom prst="rect">
+                <a:avLst/>
+              </a:prstGeom>
+              <a:noFill/>
+            </p:spPr>
+            <p:txBody>
+              <a:bodyPr wrap="none" lIns="72000" tIns="36000" rIns="72000" bIns="36000" rtlCol="0">
+                <a:noAutofit/>
+              </a:bodyPr>
+              <a:lstStyle/>
+              <a:p>
+                <a:r>
+                  <a:rPr lang="ko-KR" altLang="en-US" sz="4400" dirty="0">
+                    <a:solidFill>
+                      <a:schemeClr val="tx1">
+                        <a:lumMod val="85000"/>
+                        <a:lumOff val="15000"/>
+                      </a:schemeClr>
+                    </a:solidFill>
+                    <a:latin typeface="페이퍼로지 6 SemiBold" pitchFamily="2" charset="-127"/>
+                    <a:ea typeface="페이퍼로지 6 SemiBold" pitchFamily="2" charset="-127"/>
+                  </a:rPr>
+                  <a:t>내용</a:t>
+                </a:r>
+              </a:p>
+            </p:txBody>
+          </p:sp>
+          <p:sp>
+            <p:nvSpPr>
+              <p:cNvPr id="1038" name="TextBox 1037">
+                <a:extLst>
+                  <a:ext uri="{FF2B5EF4-FFF2-40B4-BE49-F238E27FC236}">
+                    <a16:creationId xmlns:a16="http://schemas.microsoft.com/office/drawing/2014/main" id="{7503E29B-D0E0-0503-67B1-56CF4DFF6690}"/>
+                  </a:ext>
+                </a:extLst>
+              </p:cNvPr>
+              <p:cNvSpPr txBox="1"/>
+              <p:nvPr/>
+            </p:nvSpPr>
+            <p:spPr>
+              <a:xfrm>
+                <a:off x="2422475" y="16080886"/>
+                <a:ext cx="1006031" cy="831516"/>
+              </a:xfrm>
+              <a:prstGeom prst="rect">
+                <a:avLst/>
+              </a:prstGeom>
+              <a:noFill/>
+            </p:spPr>
+            <p:txBody>
+              <a:bodyPr wrap="none" rtlCol="0" anchor="ctr">
+                <a:spAutoFit/>
+              </a:bodyPr>
+              <a:lstStyle/>
+              <a:p>
+                <a:r>
+                  <a:rPr lang="en-US" altLang="ko-KR" sz="4800" dirty="0">
+                    <a:solidFill>
+                      <a:schemeClr val="accent2"/>
+                    </a:solidFill>
+                    <a:latin typeface="페이퍼로지 8 ExtraBold" pitchFamily="2" charset="-127"/>
+                    <a:ea typeface="페이퍼로지 8 ExtraBold" pitchFamily="2" charset="-127"/>
+                  </a:rPr>
+                  <a:t>03</a:t>
+                </a:r>
+                <a:endParaRPr lang="ko-KR" altLang="en-US" sz="4800" dirty="0">
                   <a:solidFill>
                     <a:schemeClr val="accent2"/>
                   </a:solidFill>
                   <a:latin typeface="페이퍼로지 8 ExtraBold" pitchFamily="2" charset="-127"/>
                   <a:ea typeface="페이퍼로지 8 ExtraBold" pitchFamily="2" charset="-127"/>
-                </a:rPr>
-                <a:t>03</a:t>
-              </a:r>
-              <a:endParaRPr lang="ko-KR" altLang="en-US" sz="4800" dirty="0">
+                </a:endParaRPr>
+              </a:p>
+            </p:txBody>
+          </p:sp>
+          <p:sp>
+            <p:nvSpPr>
+              <p:cNvPr id="1033" name="TextBox 1032">
+                <a:extLst>
+                  <a:ext uri="{FF2B5EF4-FFF2-40B4-BE49-F238E27FC236}">
+                    <a16:creationId xmlns:a16="http://schemas.microsoft.com/office/drawing/2014/main" id="{7A48D8B8-7FD9-8E45-2922-0A4DBEF638EE}"/>
+                  </a:ext>
+                </a:extLst>
+              </p:cNvPr>
+              <p:cNvSpPr txBox="1"/>
+              <p:nvPr/>
+            </p:nvSpPr>
+            <p:spPr>
+              <a:xfrm>
+                <a:off x="6031031" y="16134388"/>
+                <a:ext cx="12812659" cy="5187055"/>
+              </a:xfrm>
+              <a:prstGeom prst="rect">
+                <a:avLst/>
+              </a:prstGeom>
+              <a:noFill/>
+              <a:ln>
+                <a:noFill/>
+              </a:ln>
+            </p:spPr>
+            <p:txBody>
+              <a:bodyPr wrap="square" lIns="72000" tIns="36000" rIns="72000" bIns="36000" rtlCol="0" anchor="t">
+                <a:normAutofit/>
+              </a:bodyPr>
+              <a:lstStyle/>
+              <a:p>
+                <a:pPr marL="720000" marR="0" lvl="0" indent="-720000" algn="l" defTabSz="2159996" rtl="0" eaLnBrk="1" fontAlgn="auto" latinLnBrk="1" hangingPunct="1">
+                  <a:spcAft>
+                    <a:spcPts val="1200"/>
+                  </a:spcAft>
+                  <a:buClr>
+                    <a:schemeClr val="accent2"/>
+                  </a:buClr>
+                  <a:buSzTx/>
+                  <a:buFont typeface="프리젠테이션 4 Regular" pitchFamily="2" charset="-127"/>
+                  <a:buChar char=""/>
+                </a:pPr>
+                <a:r>
+                  <a:rPr lang="ko-KR" altLang="en-US" sz="4000" dirty="0">
+                    <a:solidFill>
+                      <a:schemeClr val="tx1">
+                        <a:lumMod val="95000"/>
+                        <a:lumOff val="5000"/>
+                      </a:schemeClr>
+                    </a:solidFill>
+                  </a:rPr>
+                  <a:t>연습 모드 : 과목 선택 후 랜덤 출제되며 문제를 풀고 바로 피드백 제공</a:t>
+                </a:r>
+              </a:p>
+              <a:p>
+                <a:pPr marL="720000" marR="0" lvl="0" indent="-720000" algn="l" defTabSz="2159996" rtl="0" eaLnBrk="1" fontAlgn="auto" latinLnBrk="1" hangingPunct="1">
+                  <a:spcAft>
+                    <a:spcPts val="1200"/>
+                  </a:spcAft>
+                  <a:buClr>
+                    <a:schemeClr val="accent2"/>
+                  </a:buClr>
+                  <a:buSzTx/>
+                  <a:buFont typeface="프리젠테이션 4 Regular" pitchFamily="2" charset="-127"/>
+                  <a:buChar char=""/>
+                </a:pPr>
+                <a:r>
+                  <a:rPr lang="ko-KR" altLang="en-US" sz="4000" dirty="0">
+                    <a:solidFill>
+                      <a:schemeClr val="tx1">
+                        <a:lumMod val="95000"/>
+                        <a:lumOff val="5000"/>
+                      </a:schemeClr>
+                    </a:solidFill>
+                  </a:rPr>
+                  <a:t>시험 모드 : 문제 수 지정, 종료 후 점수 및 오답 해설 제공</a:t>
+                </a:r>
+              </a:p>
+              <a:p>
+                <a:pPr marL="720000" marR="0" lvl="0" indent="-720000" algn="l" defTabSz="2159996" rtl="0" eaLnBrk="1" fontAlgn="auto" latinLnBrk="1" hangingPunct="1">
+                  <a:spcAft>
+                    <a:spcPts val="1200"/>
+                  </a:spcAft>
+                  <a:buClr>
+                    <a:schemeClr val="accent2"/>
+                  </a:buClr>
+                  <a:buSzTx/>
+                  <a:buFont typeface="프리젠테이션 4 Regular" pitchFamily="2" charset="-127"/>
+                  <a:buChar char=""/>
+                </a:pPr>
+                <a:r>
+                  <a:rPr lang="ko-KR" altLang="en-US" sz="4000" dirty="0">
+                    <a:solidFill>
+                      <a:schemeClr val="tx1">
+                        <a:lumMod val="95000"/>
+                        <a:lumOff val="5000"/>
+                      </a:schemeClr>
+                    </a:solidFill>
+                  </a:rPr>
+                  <a:t>게임 모드 : 몬스터 처치(HP바·콤보·120초) / 무한의 탑(목숨3·5콤보 회복·10층 보스)</a:t>
+                </a:r>
+              </a:p>
+              <a:p>
+                <a:pPr marL="720000" marR="0" lvl="0" indent="-720000" algn="l" defTabSz="2159996" rtl="0" eaLnBrk="1" fontAlgn="auto" latinLnBrk="1" hangingPunct="1">
+                  <a:spcAft>
+                    <a:spcPts val="1200"/>
+                  </a:spcAft>
+                  <a:buClr>
+                    <a:schemeClr val="accent2"/>
+                  </a:buClr>
+                  <a:buSzTx/>
+                  <a:buFont typeface="프리젠테이션 4 Regular" pitchFamily="2" charset="-127"/>
+                  <a:buChar char=""/>
+                </a:pPr>
+                <a:r>
+                  <a:rPr lang="ko-KR" altLang="en-US" sz="4000" dirty="0">
+                    <a:solidFill>
+                      <a:schemeClr val="tx1">
+                        <a:lumMod val="95000"/>
+                        <a:lumOff val="5000"/>
+                      </a:schemeClr>
+                    </a:solidFill>
+                  </a:rPr>
+                  <a:t>검색/제작 : 키워드 검색, CSV로 문제 직접 추가 및 저장</a:t>
+                </a:r>
+              </a:p>
+              <a:p>
+                <a:pPr marL="720000" marR="0" lvl="0" indent="-720000" algn="l" defTabSz="2159996" rtl="0" eaLnBrk="1" fontAlgn="auto" latinLnBrk="1" hangingPunct="1">
+                  <a:spcAft>
+                    <a:spcPts val="1200"/>
+                  </a:spcAft>
+                  <a:buClr>
+                    <a:schemeClr val="accent2"/>
+                  </a:buClr>
+                  <a:buSzTx/>
+                  <a:buFont typeface="프리젠테이션 4 Regular" pitchFamily="2" charset="-127"/>
+                  <a:buChar char=""/>
+                </a:pPr>
+                <a:r>
+                  <a:rPr lang="ko-KR" altLang="en-US" sz="4000" dirty="0">
+                    <a:solidFill>
+                      <a:schemeClr val="tx1">
+                        <a:lumMod val="95000"/>
+                        <a:lumOff val="5000"/>
+                      </a:schemeClr>
+                    </a:solidFill>
+                  </a:rPr>
+                  <a:t>OOP 설계 : struct 캡슐화, .h/.cpp 모듈 분리, extern 공유, STL 컨테이너 활용</a:t>
+                </a:r>
+              </a:p>
+            </p:txBody>
+          </p:sp>
+          <p:cxnSp>
+            <p:nvCxnSpPr>
+              <p:cNvPr id="1036" name="직선 연결선 1035">
+                <a:extLst>
+                  <a:ext uri="{FF2B5EF4-FFF2-40B4-BE49-F238E27FC236}">
+                    <a16:creationId xmlns:a16="http://schemas.microsoft.com/office/drawing/2014/main" id="{48C2C7F7-04CF-2657-F262-EDA62F05528A}"/>
+                  </a:ext>
+                </a:extLst>
+              </p:cNvPr>
+              <p:cNvCxnSpPr>
+                <a:cxnSpLocks/>
+              </p:cNvCxnSpPr>
+              <p:nvPr/>
+            </p:nvCxnSpPr>
+            <p:spPr>
+              <a:xfrm>
+                <a:off x="3923539" y="16480618"/>
+                <a:ext cx="2004816" cy="0"/>
+              </a:xfrm>
+              <a:prstGeom prst="line">
+                <a:avLst/>
+              </a:prstGeom>
+              <a:ln w="47625" cap="rnd">
                 <a:solidFill>
-                  <a:schemeClr val="accent2"/>
+                  <a:schemeClr val="tx2">
+                    <a:lumMod val="40000"/>
+                    <a:lumOff val="60000"/>
+                  </a:schemeClr>
                 </a:solidFill>
-                <a:latin typeface="페이퍼로지 8 ExtraBold" pitchFamily="2" charset="-127"/>
-                <a:ea typeface="페이퍼로지 8 ExtraBold" pitchFamily="2" charset="-127"/>
-              </a:endParaRPr>
-            </a:p>
-          </p:txBody>
-        </p:sp>
-        <p:sp>
-          <p:nvSpPr>
-            <p:cNvPr id="1033" name="TextBox 1032">
-              <a:extLst>
-                <a:ext uri="{FF2B5EF4-FFF2-40B4-BE49-F238E27FC236}">
-                  <a16:creationId xmlns:a16="http://schemas.microsoft.com/office/drawing/2014/main" id="{7A48D8B8-7FD9-8E45-2922-0A4DBEF638EE}"/>
-                </a:ext>
-              </a:extLst>
-            </p:cNvPr>
-            <p:cNvSpPr txBox="1"/>
-            <p:nvPr/>
-          </p:nvSpPr>
-          <p:spPr>
-            <a:xfrm>
-              <a:off x="6408575" y="16134388"/>
-              <a:ext cx="12812659" cy="5187055"/>
-            </a:xfrm>
-            <a:prstGeom prst="rect">
-              <a:avLst/>
-            </a:prstGeom>
-            <a:noFill/>
-            <a:ln>
-              <a:noFill/>
-            </a:ln>
-          </p:spPr>
-          <p:txBody>
-            <a:bodyPr wrap="square" lIns="72000" tIns="36000" rIns="72000" bIns="36000" rtlCol="0" anchor="t">
-              <a:normAutofit/>
-            </a:bodyPr>
-            <a:lstStyle/>
-            <a:p>
-              <a:pPr marL="720000" marR="0" lvl="0" indent="-720000" algn="l" defTabSz="2159996" rtl="0" eaLnBrk="1" fontAlgn="auto" latinLnBrk="1" hangingPunct="1">
-                <a:spcAft>
-                  <a:spcPts val="1200"/>
-                </a:spcAft>
-                <a:buClr>
-                  <a:schemeClr val="accent2"/>
-                </a:buClr>
-                <a:buSzTx/>
-                <a:buFont typeface="프리젠테이션 4 Regular" pitchFamily="2" charset="-127"/>
-                <a:buChar char=""/>
-              </a:pPr>
-              <a:r>
-                <a:rPr lang="ko-KR" altLang="en-US" sz="4000" dirty="0">
-                  <a:solidFill>
-                    <a:schemeClr val="tx1">
-                      <a:lumMod val="95000"/>
-                      <a:lumOff val="5000"/>
-                    </a:schemeClr>
-                  </a:solidFill>
-                </a:rPr>
-                <a:t>연습 모드 : 과목 선택 후 랜덤 출제되며 문제를 풀고 바로 피드백 제공</a:t>
-              </a:r>
-            </a:p>
-            <a:p>
-              <a:pPr marL="720000" marR="0" lvl="0" indent="-720000" algn="l" defTabSz="2159996" rtl="0" eaLnBrk="1" fontAlgn="auto" latinLnBrk="1" hangingPunct="1">
-                <a:spcAft>
-                  <a:spcPts val="1200"/>
-                </a:spcAft>
-                <a:buClr>
-                  <a:schemeClr val="accent2"/>
-                </a:buClr>
-                <a:buSzTx/>
-                <a:buFont typeface="프리젠테이션 4 Regular" pitchFamily="2" charset="-127"/>
-                <a:buChar char=""/>
-              </a:pPr>
-              <a:r>
-                <a:rPr lang="ko-KR" altLang="en-US" sz="4000" dirty="0">
-                  <a:solidFill>
-                    <a:schemeClr val="tx1">
-                      <a:lumMod val="95000"/>
-                      <a:lumOff val="5000"/>
-                    </a:schemeClr>
-                  </a:solidFill>
-                </a:rPr>
-                <a:t>시험 모드 : 문제 수 지정, 종료 후 점수 및 오답 해설 제공</a:t>
-              </a:r>
-            </a:p>
-            <a:p>
-              <a:pPr marL="720000" marR="0" lvl="0" indent="-720000" algn="l" defTabSz="2159996" rtl="0" eaLnBrk="1" fontAlgn="auto" latinLnBrk="1" hangingPunct="1">
-                <a:spcAft>
-                  <a:spcPts val="1200"/>
-                </a:spcAft>
-                <a:buClr>
-                  <a:schemeClr val="accent2"/>
-                </a:buClr>
-                <a:buSzTx/>
-                <a:buFont typeface="프리젠테이션 4 Regular" pitchFamily="2" charset="-127"/>
-                <a:buChar char=""/>
-              </a:pPr>
-              <a:r>
-                <a:rPr lang="ko-KR" altLang="en-US" sz="4000" dirty="0">
-                  <a:solidFill>
-                    <a:schemeClr val="tx1">
-                      <a:lumMod val="95000"/>
-                      <a:lumOff val="5000"/>
-                    </a:schemeClr>
-                  </a:solidFill>
-                </a:rPr>
-                <a:t>게임 모드 : 몬스터 처치(HP바·콤보·120초) / 무한의 탑(목숨3·5콤보 회복·10층 보스)</a:t>
-              </a:r>
-            </a:p>
-            <a:p>
-              <a:pPr marL="720000" marR="0" lvl="0" indent="-720000" algn="l" defTabSz="2159996" rtl="0" eaLnBrk="1" fontAlgn="auto" latinLnBrk="1" hangingPunct="1">
-                <a:spcAft>
-                  <a:spcPts val="1200"/>
-                </a:spcAft>
-                <a:buClr>
-                  <a:schemeClr val="accent2"/>
-                </a:buClr>
-                <a:buSzTx/>
-                <a:buFont typeface="프리젠테이션 4 Regular" pitchFamily="2" charset="-127"/>
-                <a:buChar char=""/>
-              </a:pPr>
-              <a:r>
-                <a:rPr lang="ko-KR" altLang="en-US" sz="4000" dirty="0">
-                  <a:solidFill>
-                    <a:schemeClr val="tx1">
-                      <a:lumMod val="95000"/>
-                      <a:lumOff val="5000"/>
-                    </a:schemeClr>
-                  </a:solidFill>
-                </a:rPr>
-                <a:t>검색/제작 : 키워드 검색, CSV로 문제 직접 추가 및 저장</a:t>
-              </a:r>
-            </a:p>
-            <a:p>
-              <a:pPr marL="720000" marR="0" lvl="0" indent="-720000" algn="l" defTabSz="2159996" rtl="0" eaLnBrk="1" fontAlgn="auto" latinLnBrk="1" hangingPunct="1">
-                <a:spcAft>
-                  <a:spcPts val="1200"/>
-                </a:spcAft>
-                <a:buClr>
-                  <a:schemeClr val="accent2"/>
-                </a:buClr>
-                <a:buSzTx/>
-                <a:buFont typeface="프리젠테이션 4 Regular" pitchFamily="2" charset="-127"/>
-                <a:buChar char=""/>
-              </a:pPr>
-              <a:r>
-                <a:rPr lang="ko-KR" altLang="en-US" sz="4000" dirty="0">
-                  <a:solidFill>
-                    <a:schemeClr val="tx1">
-                      <a:lumMod val="95000"/>
-                      <a:lumOff val="5000"/>
-                    </a:schemeClr>
-                  </a:solidFill>
-                </a:rPr>
-                <a:t>OOP 설계 : struct 캡슐화, .h/.cpp 모듈 분리, extern 공유, STL 컨테이너 활용</a:t>
-              </a:r>
-            </a:p>
-          </p:txBody>
-        </p:sp>
-        <p:cxnSp>
-          <p:nvCxnSpPr>
-            <p:cNvPr id="1036" name="직선 연결선 1035">
-              <a:extLst>
-                <a:ext uri="{FF2B5EF4-FFF2-40B4-BE49-F238E27FC236}">
-                  <a16:creationId xmlns:a16="http://schemas.microsoft.com/office/drawing/2014/main" id="{48C2C7F7-04CF-2657-F262-EDA62F05528A}"/>
-                </a:ext>
-              </a:extLst>
-            </p:cNvPr>
-            <p:cNvCxnSpPr>
-              <a:cxnSpLocks/>
-            </p:cNvCxnSpPr>
-            <p:nvPr/>
-          </p:nvCxnSpPr>
-          <p:spPr>
-            <a:xfrm>
-              <a:off x="3923539" y="16480618"/>
-              <a:ext cx="2004816" cy="0"/>
-            </a:xfrm>
-            <a:prstGeom prst="line">
-              <a:avLst/>
-            </a:prstGeom>
-            <a:ln w="47625" cap="rnd">
-              <a:solidFill>
-                <a:schemeClr val="tx2">
-                  <a:lumMod val="40000"/>
-                  <a:lumOff val="60000"/>
-                </a:schemeClr>
-              </a:solidFill>
-              <a:prstDash val="sysDot"/>
-              <a:round/>
-            </a:ln>
-          </p:spPr>
-          <p:style>
-            <a:lnRef idx="1">
-              <a:schemeClr val="accent1"/>
-            </a:lnRef>
-            <a:fillRef idx="0">
-              <a:schemeClr val="accent1"/>
-            </a:fillRef>
-            <a:effectRef idx="0">
-              <a:schemeClr val="accent1"/>
-            </a:effectRef>
-            <a:fontRef idx="minor">
-              <a:schemeClr val="tx1"/>
-            </a:fontRef>
-          </p:style>
-        </p:cxnSp>
+                <a:prstDash val="sysDot"/>
+                <a:round/>
+              </a:ln>
+            </p:spPr>
+            <p:style>
+              <a:lnRef idx="1">
+                <a:schemeClr val="accent1"/>
+              </a:lnRef>
+              <a:fillRef idx="0">
+                <a:schemeClr val="accent1"/>
+              </a:fillRef>
+              <a:effectRef idx="0">
+                <a:schemeClr val="accent1"/>
+              </a:effectRef>
+              <a:fontRef idx="minor">
+                <a:schemeClr val="tx1"/>
+              </a:fontRef>
+            </p:style>
+          </p:cxnSp>
+        </p:grpSp>
       </p:grpSp>
       <p:sp>
         <p:nvSpPr>
@@ -27956,10 +28988,10 @@
       </p:grpSp>
       <p:grpSp>
         <p:nvGrpSpPr>
-          <p:cNvPr id="4" name="그룹 3">
+          <p:cNvPr id="67" name="그룹 66">
             <a:extLst>
               <a:ext uri="{FF2B5EF4-FFF2-40B4-BE49-F238E27FC236}">
-                <a16:creationId xmlns:a16="http://schemas.microsoft.com/office/drawing/2014/main" id="{6A778F85-1F54-F8AC-A99B-9492A33EAFF8}"/>
+                <a16:creationId xmlns:a16="http://schemas.microsoft.com/office/drawing/2014/main" id="{4E1C564F-46DA-F3EC-0A9F-2097BD33A46C}"/>
               </a:ext>
             </a:extLst>
           </p:cNvPr>
@@ -27968,18 +29000,18 @@
         </p:nvGrpSpPr>
         <p:grpSpPr>
           <a:xfrm>
-            <a:off x="2437269" y="19872052"/>
-            <a:ext cx="16393708" cy="8793676"/>
-            <a:chOff x="2437269" y="19872052"/>
-            <a:chExt cx="16393708" cy="8793676"/>
+            <a:off x="1510729" y="19193197"/>
+            <a:ext cx="18531245" cy="8887767"/>
+            <a:chOff x="1510729" y="19193197"/>
+            <a:chExt cx="18531245" cy="8887767"/>
           </a:xfrm>
         </p:grpSpPr>
         <p:grpSp>
           <p:nvGrpSpPr>
-            <p:cNvPr id="31" name="그룹 30">
+            <p:cNvPr id="62" name="그룹 61">
               <a:extLst>
                 <a:ext uri="{FF2B5EF4-FFF2-40B4-BE49-F238E27FC236}">
-                  <a16:creationId xmlns:a16="http://schemas.microsoft.com/office/drawing/2014/main" id="{16317365-A9A4-173B-E71C-EC8B12DB5AE1}"/>
+                  <a16:creationId xmlns:a16="http://schemas.microsoft.com/office/drawing/2014/main" id="{2D6F0E9F-C13A-F4D5-AB3C-2E34E9AE0583}"/>
                 </a:ext>
               </a:extLst>
             </p:cNvPr>
@@ -27988,205 +29020,689 @@
           </p:nvGrpSpPr>
           <p:grpSpPr>
             <a:xfrm>
-              <a:off x="2437269" y="19872052"/>
-              <a:ext cx="16393708" cy="8793676"/>
-              <a:chOff x="2437269" y="19872052"/>
-              <a:chExt cx="16393708" cy="8793676"/>
+              <a:off x="1510729" y="19193197"/>
+              <a:ext cx="18531245" cy="8887767"/>
+              <a:chOff x="1752216" y="19748484"/>
+              <a:chExt cx="17400474" cy="9052560"/>
             </a:xfrm>
           </p:grpSpPr>
-          <p:cxnSp>
-            <p:nvCxnSpPr>
-              <p:cNvPr id="6" name="직선 연결선 5">
+          <p:sp>
+            <p:nvSpPr>
+              <p:cNvPr id="27" name="Rectangle 1044">
                 <a:extLst>
                   <a:ext uri="{FF2B5EF4-FFF2-40B4-BE49-F238E27FC236}">
-                    <a16:creationId xmlns:a16="http://schemas.microsoft.com/office/drawing/2014/main" id="{26F09DE1-FBF4-CCEE-A36F-57CD7A2A0DA4}"/>
+                    <a16:creationId xmlns:a16="http://schemas.microsoft.com/office/drawing/2014/main" id="{5F2DF28A-CF93-786A-27C7-86D2AFF5CA6D}"/>
                   </a:ext>
                 </a:extLst>
               </p:cNvPr>
-              <p:cNvCxnSpPr>
-                <a:cxnSpLocks/>
-              </p:cNvCxnSpPr>
+              <p:cNvSpPr/>
               <p:nvPr/>
-            </p:nvCxnSpPr>
+            </p:nvSpPr>
             <p:spPr>
               <a:xfrm>
-                <a:off x="3923520" y="20287810"/>
-                <a:ext cx="2004816" cy="0"/>
+                <a:off x="1752216" y="19748484"/>
+                <a:ext cx="17400474" cy="9052560"/>
               </a:xfrm>
-              <a:prstGeom prst="line">
+              <a:prstGeom prst="rect">
                 <a:avLst/>
               </a:prstGeom>
-              <a:ln w="47625" cap="rnd">
-                <a:solidFill>
-                  <a:schemeClr val="tx2">
-                    <a:lumMod val="40000"/>
-                    <a:lumOff val="60000"/>
-                  </a:schemeClr>
-                </a:solidFill>
-                <a:prstDash val="sysDot"/>
-                <a:round/>
+              <a:solidFill>
+                <a:srgbClr val="F5EEF8"/>
+              </a:solidFill>
+              <a:ln w="19050">
+                <a:noFill/>
               </a:ln>
             </p:spPr>
             <p:style>
               <a:lnRef idx="1">
                 <a:schemeClr val="accent1"/>
               </a:lnRef>
-              <a:fillRef idx="0">
+              <a:fillRef idx="3">
                 <a:schemeClr val="accent1"/>
               </a:fillRef>
-              <a:effectRef idx="0">
+              <a:effectRef idx="2">
                 <a:schemeClr val="accent1"/>
               </a:effectRef>
               <a:fontRef idx="minor">
-                <a:schemeClr val="tx1"/>
+                <a:schemeClr val="lt1"/>
               </a:fontRef>
             </p:style>
-          </p:cxnSp>
-          <p:sp>
-            <p:nvSpPr>
-              <p:cNvPr id="7" name="TextBox 6">
-                <a:extLst>
-                  <a:ext uri="{FF2B5EF4-FFF2-40B4-BE49-F238E27FC236}">
-                    <a16:creationId xmlns:a16="http://schemas.microsoft.com/office/drawing/2014/main" id="{8B0C43D6-061C-B655-44F1-23F1E93DD143}"/>
-                  </a:ext>
-                </a:extLst>
-              </p:cNvPr>
-              <p:cNvSpPr txBox="1"/>
-              <p:nvPr/>
-            </p:nvSpPr>
-            <p:spPr>
-              <a:xfrm>
-                <a:off x="2437269" y="20862194"/>
-                <a:ext cx="2916000" cy="769441"/>
-              </a:xfrm>
-              <a:prstGeom prst="rect">
-                <a:avLst/>
-              </a:prstGeom>
-              <a:noFill/>
-            </p:spPr>
             <p:txBody>
-              <a:bodyPr wrap="none" lIns="72000" tIns="36000" rIns="72000" bIns="36000" rtlCol="0">
-                <a:noAutofit/>
-              </a:bodyPr>
+              <a:bodyPr rtlCol="0" anchor="ctr"/>
               <a:lstStyle/>
               <a:p>
-                <a:r>
-                  <a:rPr lang="ko-KR" altLang="en-US" sz="4400" dirty="0">
-                    <a:solidFill>
-                      <a:schemeClr val="tx1">
-                        <a:lumMod val="85000"/>
-                        <a:lumOff val="15000"/>
-                      </a:schemeClr>
-                    </a:solidFill>
-                    <a:latin typeface="페이퍼로지 6 SemiBold" pitchFamily="2" charset="-127"/>
-                    <a:ea typeface="페이퍼로지 6 SemiBold" pitchFamily="2" charset="-127"/>
-                  </a:rPr>
-                  <a:t>결과</a:t>
-                </a:r>
+                <a:pPr algn="ctr"/>
+                <a:endParaRPr dirty="0"/>
               </a:p>
             </p:txBody>
           </p:sp>
           <p:sp>
             <p:nvSpPr>
-              <p:cNvPr id="8" name="TextBox 7">
+              <p:cNvPr id="28" name="Rectangle 1045">
                 <a:extLst>
                   <a:ext uri="{FF2B5EF4-FFF2-40B4-BE49-F238E27FC236}">
-                    <a16:creationId xmlns:a16="http://schemas.microsoft.com/office/drawing/2014/main" id="{29955F92-49CA-F488-AB3B-A44E2BCC073D}"/>
+                    <a16:creationId xmlns:a16="http://schemas.microsoft.com/office/drawing/2014/main" id="{98F3EFDD-DCA0-F130-3273-9FB038A85A50}"/>
                   </a:ext>
                 </a:extLst>
               </p:cNvPr>
-              <p:cNvSpPr txBox="1"/>
+              <p:cNvSpPr/>
               <p:nvPr/>
             </p:nvSpPr>
             <p:spPr>
               <a:xfrm>
-                <a:off x="2437269" y="19872052"/>
-                <a:ext cx="1006032" cy="831516"/>
+                <a:off x="1752216" y="19748484"/>
+                <a:ext cx="241195" cy="9052560"/>
               </a:xfrm>
               <a:prstGeom prst="rect">
                 <a:avLst/>
               </a:prstGeom>
-              <a:noFill/>
+              <a:solidFill>
+                <a:srgbClr val="4A148C"/>
+              </a:solidFill>
+              <a:ln>
+                <a:noFill/>
+              </a:ln>
             </p:spPr>
+            <p:style>
+              <a:lnRef idx="1">
+                <a:schemeClr val="accent1"/>
+              </a:lnRef>
+              <a:fillRef idx="3">
+                <a:schemeClr val="accent1"/>
+              </a:fillRef>
+              <a:effectRef idx="2">
+                <a:schemeClr val="accent1"/>
+              </a:effectRef>
+              <a:fontRef idx="minor">
+                <a:schemeClr val="lt1"/>
+              </a:fontRef>
+            </p:style>
             <p:txBody>
-              <a:bodyPr wrap="none" rtlCol="0" anchor="ctr">
-                <a:spAutoFit/>
-              </a:bodyPr>
+              <a:bodyPr rtlCol="0" anchor="ctr"/>
               <a:lstStyle/>
               <a:p>
-                <a:r>
-                  <a:rPr lang="en-US" altLang="ko-KR" sz="4800" dirty="0">
+                <a:pPr algn="ctr"/>
+                <a:endParaRPr/>
+              </a:p>
+            </p:txBody>
+          </p:sp>
+          <p:sp>
+            <p:nvSpPr>
+              <p:cNvPr id="29" name="Rounded Rectangle 1049">
+                <a:extLst>
+                  <a:ext uri="{FF2B5EF4-FFF2-40B4-BE49-F238E27FC236}">
+                    <a16:creationId xmlns:a16="http://schemas.microsoft.com/office/drawing/2014/main" id="{A9B21C43-B7B3-4308-4D05-4D179DFA04B0}"/>
+                  </a:ext>
+                </a:extLst>
+              </p:cNvPr>
+              <p:cNvSpPr/>
+              <p:nvPr/>
+            </p:nvSpPr>
+            <p:spPr>
+              <a:xfrm>
+                <a:off x="2462567" y="19933866"/>
+                <a:ext cx="900000" cy="900000"/>
+              </a:xfrm>
+              <a:prstGeom prst="roundRect">
+                <a:avLst>
+                  <a:gd name="adj" fmla="val 8000"/>
+                </a:avLst>
+              </a:prstGeom>
+              <a:solidFill>
+                <a:srgbClr val="4A148C"/>
+              </a:solidFill>
+              <a:ln>
+                <a:noFill/>
+              </a:ln>
+            </p:spPr>
+            <p:style>
+              <a:lnRef idx="1">
+                <a:schemeClr val="accent1"/>
+              </a:lnRef>
+              <a:fillRef idx="3">
+                <a:schemeClr val="accent1"/>
+              </a:fillRef>
+              <a:effectRef idx="2">
+                <a:schemeClr val="accent1"/>
+              </a:effectRef>
+              <a:fontRef idx="minor">
+                <a:schemeClr val="lt1"/>
+              </a:fontRef>
+            </p:style>
+            <p:txBody>
+              <a:bodyPr rtlCol="0" anchor="ctr"/>
+              <a:lstStyle/>
+              <a:p>
+                <a:pPr algn="ctr"/>
+                <a:endParaRPr/>
+              </a:p>
+            </p:txBody>
+          </p:sp>
+          <p:sp>
+            <p:nvSpPr>
+              <p:cNvPr id="33" name="Diamond 1082">
+                <a:extLst>
+                  <a:ext uri="{FF2B5EF4-FFF2-40B4-BE49-F238E27FC236}">
+                    <a16:creationId xmlns:a16="http://schemas.microsoft.com/office/drawing/2014/main" id="{81CD8690-8B24-EDA5-FCEA-D07552D563E2}"/>
+                  </a:ext>
+                </a:extLst>
+              </p:cNvPr>
+              <p:cNvSpPr/>
+              <p:nvPr/>
+            </p:nvSpPr>
+            <p:spPr>
+              <a:xfrm>
+                <a:off x="18549703" y="21138372"/>
+                <a:ext cx="344564" cy="365760"/>
+              </a:xfrm>
+              <a:prstGeom prst="diamond">
+                <a:avLst/>
+              </a:prstGeom>
+              <a:solidFill>
+                <a:srgbClr val="CE93D8"/>
+              </a:solidFill>
+              <a:ln>
+                <a:noFill/>
+              </a:ln>
+            </p:spPr>
+            <p:style>
+              <a:lnRef idx="1">
+                <a:schemeClr val="accent1"/>
+              </a:lnRef>
+              <a:fillRef idx="3">
+                <a:schemeClr val="accent1"/>
+              </a:fillRef>
+              <a:effectRef idx="2">
+                <a:schemeClr val="accent1"/>
+              </a:effectRef>
+              <a:fontRef idx="minor">
+                <a:schemeClr val="lt1"/>
+              </a:fontRef>
+            </p:style>
+            <p:txBody>
+              <a:bodyPr rtlCol="0" anchor="ctr"/>
+              <a:lstStyle/>
+              <a:p>
+                <a:pPr algn="ctr"/>
+                <a:endParaRPr/>
+              </a:p>
+            </p:txBody>
+          </p:sp>
+          <p:sp>
+            <p:nvSpPr>
+              <p:cNvPr id="34" name="Rounded Rectangle 1083">
+                <a:extLst>
+                  <a:ext uri="{FF2B5EF4-FFF2-40B4-BE49-F238E27FC236}">
+                    <a16:creationId xmlns:a16="http://schemas.microsoft.com/office/drawing/2014/main" id="{5DB7FA49-3F16-9CB7-8EAF-09A168BA5361}"/>
+                  </a:ext>
+                </a:extLst>
+              </p:cNvPr>
+              <p:cNvSpPr/>
+              <p:nvPr/>
+            </p:nvSpPr>
+            <p:spPr>
+              <a:xfrm>
+                <a:off x="18618616" y="23150052"/>
+                <a:ext cx="223966" cy="237744"/>
+              </a:xfrm>
+              <a:prstGeom prst="roundRect">
+                <a:avLst/>
+              </a:prstGeom>
+              <a:solidFill>
+                <a:srgbClr val="E1BEE7"/>
+              </a:solidFill>
+              <a:ln>
+                <a:noFill/>
+              </a:ln>
+            </p:spPr>
+            <p:style>
+              <a:lnRef idx="1">
+                <a:schemeClr val="accent1"/>
+              </a:lnRef>
+              <a:fillRef idx="3">
+                <a:schemeClr val="accent1"/>
+              </a:fillRef>
+              <a:effectRef idx="2">
+                <a:schemeClr val="accent1"/>
+              </a:effectRef>
+              <a:fontRef idx="minor">
+                <a:schemeClr val="lt1"/>
+              </a:fontRef>
+            </p:style>
+            <p:txBody>
+              <a:bodyPr rtlCol="0" anchor="ctr"/>
+              <a:lstStyle/>
+              <a:p>
+                <a:pPr algn="ctr"/>
+                <a:endParaRPr/>
+              </a:p>
+            </p:txBody>
+          </p:sp>
+          <p:sp>
+            <p:nvSpPr>
+              <p:cNvPr id="35" name="Rectangle 1084">
+                <a:extLst>
+                  <a:ext uri="{FF2B5EF4-FFF2-40B4-BE49-F238E27FC236}">
+                    <a16:creationId xmlns:a16="http://schemas.microsoft.com/office/drawing/2014/main" id="{6C5DB995-E7B3-9AFC-3E23-6275C332A298}"/>
+                  </a:ext>
+                </a:extLst>
+              </p:cNvPr>
+              <p:cNvSpPr/>
+              <p:nvPr/>
+            </p:nvSpPr>
+            <p:spPr>
+              <a:xfrm>
+                <a:off x="18653072" y="24978852"/>
+                <a:ext cx="155054" cy="164592"/>
+              </a:xfrm>
+              <a:prstGeom prst="rect">
+                <a:avLst/>
+              </a:prstGeom>
+              <a:solidFill>
+                <a:srgbClr val="F3E5F5"/>
+              </a:solidFill>
+              <a:ln>
+                <a:noFill/>
+              </a:ln>
+            </p:spPr>
+            <p:style>
+              <a:lnRef idx="1">
+                <a:schemeClr val="accent1"/>
+              </a:lnRef>
+              <a:fillRef idx="3">
+                <a:schemeClr val="accent1"/>
+              </a:fillRef>
+              <a:effectRef idx="2">
+                <a:schemeClr val="accent1"/>
+              </a:effectRef>
+              <a:fontRef idx="minor">
+                <a:schemeClr val="lt1"/>
+              </a:fontRef>
+            </p:style>
+            <p:txBody>
+              <a:bodyPr rtlCol="0" anchor="ctr"/>
+              <a:lstStyle/>
+              <a:p>
+                <a:pPr algn="ctr"/>
+                <a:endParaRPr/>
+              </a:p>
+            </p:txBody>
+          </p:sp>
+          <p:sp>
+            <p:nvSpPr>
+              <p:cNvPr id="36" name="Diamond 1085">
+                <a:extLst>
+                  <a:ext uri="{FF2B5EF4-FFF2-40B4-BE49-F238E27FC236}">
+                    <a16:creationId xmlns:a16="http://schemas.microsoft.com/office/drawing/2014/main" id="{B39B9622-F9B9-7624-3927-D102C9382159}"/>
+                  </a:ext>
+                </a:extLst>
+              </p:cNvPr>
+              <p:cNvSpPr/>
+              <p:nvPr/>
+            </p:nvSpPr>
+            <p:spPr>
+              <a:xfrm>
+                <a:off x="18549703" y="26807652"/>
+                <a:ext cx="344564" cy="365760"/>
+              </a:xfrm>
+              <a:prstGeom prst="diamond">
+                <a:avLst/>
+              </a:prstGeom>
+              <a:solidFill>
+                <a:srgbClr val="BA68C8"/>
+              </a:solidFill>
+              <a:ln>
+                <a:noFill/>
+              </a:ln>
+            </p:spPr>
+            <p:style>
+              <a:lnRef idx="1">
+                <a:schemeClr val="accent1"/>
+              </a:lnRef>
+              <a:fillRef idx="3">
+                <a:schemeClr val="accent1"/>
+              </a:fillRef>
+              <a:effectRef idx="2">
+                <a:schemeClr val="accent1"/>
+              </a:effectRef>
+              <a:fontRef idx="minor">
+                <a:schemeClr val="lt1"/>
+              </a:fontRef>
+            </p:style>
+            <p:txBody>
+              <a:bodyPr rtlCol="0" anchor="ctr"/>
+              <a:lstStyle/>
+              <a:p>
+                <a:pPr algn="ctr"/>
+                <a:endParaRPr dirty="0"/>
+              </a:p>
+            </p:txBody>
+          </p:sp>
+        </p:grpSp>
+        <p:grpSp>
+          <p:nvGrpSpPr>
+            <p:cNvPr id="4" name="그룹 3">
+              <a:extLst>
+                <a:ext uri="{FF2B5EF4-FFF2-40B4-BE49-F238E27FC236}">
+                  <a16:creationId xmlns:a16="http://schemas.microsoft.com/office/drawing/2014/main" id="{6A778F85-1F54-F8AC-A99B-9492A33EAFF8}"/>
+                </a:ext>
+              </a:extLst>
+            </p:cNvPr>
+            <p:cNvGrpSpPr/>
+            <p:nvPr/>
+          </p:nvGrpSpPr>
+          <p:grpSpPr>
+            <a:xfrm>
+              <a:off x="2176047" y="19358581"/>
+              <a:ext cx="16700517" cy="8325750"/>
+              <a:chOff x="2389863" y="19913868"/>
+              <a:chExt cx="16005928" cy="8325750"/>
+            </a:xfrm>
+          </p:grpSpPr>
+          <p:grpSp>
+            <p:nvGrpSpPr>
+              <p:cNvPr id="31" name="그룹 30">
+                <a:extLst>
+                  <a:ext uri="{FF2B5EF4-FFF2-40B4-BE49-F238E27FC236}">
+                    <a16:creationId xmlns:a16="http://schemas.microsoft.com/office/drawing/2014/main" id="{16317365-A9A4-173B-E71C-EC8B12DB5AE1}"/>
+                  </a:ext>
+                </a:extLst>
+              </p:cNvPr>
+              <p:cNvGrpSpPr/>
+              <p:nvPr/>
+            </p:nvGrpSpPr>
+            <p:grpSpPr>
+              <a:xfrm>
+                <a:off x="2389863" y="19913868"/>
+                <a:ext cx="16005928" cy="8325750"/>
+                <a:chOff x="2389863" y="19913868"/>
+                <a:chExt cx="16005928" cy="8325750"/>
+              </a:xfrm>
+            </p:grpSpPr>
+            <p:cxnSp>
+              <p:nvCxnSpPr>
+                <p:cNvPr id="6" name="직선 연결선 5">
+                  <a:extLst>
+                    <a:ext uri="{FF2B5EF4-FFF2-40B4-BE49-F238E27FC236}">
+                      <a16:creationId xmlns:a16="http://schemas.microsoft.com/office/drawing/2014/main" id="{26F09DE1-FBF4-CCEE-A36F-57CD7A2A0DA4}"/>
+                    </a:ext>
+                  </a:extLst>
+                </p:cNvPr>
+                <p:cNvCxnSpPr>
+                  <a:cxnSpLocks/>
+                </p:cNvCxnSpPr>
+                <p:nvPr/>
+              </p:nvCxnSpPr>
+              <p:spPr>
+                <a:xfrm>
+                  <a:off x="3923520" y="20287810"/>
+                  <a:ext cx="2004816" cy="0"/>
+                </a:xfrm>
+                <a:prstGeom prst="line">
+                  <a:avLst/>
+                </a:prstGeom>
+                <a:ln w="47625" cap="rnd">
+                  <a:solidFill>
+                    <a:schemeClr val="tx2">
+                      <a:lumMod val="40000"/>
+                      <a:lumOff val="60000"/>
+                    </a:schemeClr>
+                  </a:solidFill>
+                  <a:prstDash val="sysDot"/>
+                  <a:round/>
+                </a:ln>
+              </p:spPr>
+              <p:style>
+                <a:lnRef idx="1">
+                  <a:schemeClr val="accent1"/>
+                </a:lnRef>
+                <a:fillRef idx="0">
+                  <a:schemeClr val="accent1"/>
+                </a:fillRef>
+                <a:effectRef idx="0">
+                  <a:schemeClr val="accent1"/>
+                </a:effectRef>
+                <a:fontRef idx="minor">
+                  <a:schemeClr val="tx1"/>
+                </a:fontRef>
+              </p:style>
+            </p:cxnSp>
+            <p:sp>
+              <p:nvSpPr>
+                <p:cNvPr id="7" name="TextBox 6">
+                  <a:extLst>
+                    <a:ext uri="{FF2B5EF4-FFF2-40B4-BE49-F238E27FC236}">
+                      <a16:creationId xmlns:a16="http://schemas.microsoft.com/office/drawing/2014/main" id="{8B0C43D6-061C-B655-44F1-23F1E93DD143}"/>
+                    </a:ext>
+                  </a:extLst>
+                </p:cNvPr>
+                <p:cNvSpPr txBox="1"/>
+                <p:nvPr/>
+              </p:nvSpPr>
+              <p:spPr>
+                <a:xfrm>
+                  <a:off x="2437269" y="20862194"/>
+                  <a:ext cx="2916000" cy="769441"/>
+                </a:xfrm>
+                <a:prstGeom prst="rect">
+                  <a:avLst/>
+                </a:prstGeom>
+                <a:noFill/>
+              </p:spPr>
+              <p:txBody>
+                <a:bodyPr wrap="none" lIns="72000" tIns="36000" rIns="72000" bIns="36000" rtlCol="0">
+                  <a:noAutofit/>
+                </a:bodyPr>
+                <a:lstStyle/>
+                <a:p>
+                  <a:r>
+                    <a:rPr lang="ko-KR" altLang="en-US" sz="4400" dirty="0">
+                      <a:solidFill>
+                        <a:schemeClr val="tx1">
+                          <a:lumMod val="85000"/>
+                          <a:lumOff val="15000"/>
+                        </a:schemeClr>
+                      </a:solidFill>
+                      <a:latin typeface="페이퍼로지 6 SemiBold" pitchFamily="2" charset="-127"/>
+                      <a:ea typeface="페이퍼로지 6 SemiBold" pitchFamily="2" charset="-127"/>
+                    </a:rPr>
+                    <a:t>결과</a:t>
+                  </a:r>
+                </a:p>
+              </p:txBody>
+            </p:sp>
+            <p:sp>
+              <p:nvSpPr>
+                <p:cNvPr id="8" name="TextBox 7">
+                  <a:extLst>
+                    <a:ext uri="{FF2B5EF4-FFF2-40B4-BE49-F238E27FC236}">
+                      <a16:creationId xmlns:a16="http://schemas.microsoft.com/office/drawing/2014/main" id="{29955F92-49CA-F488-AB3B-A44E2BCC073D}"/>
+                    </a:ext>
+                  </a:extLst>
+                </p:cNvPr>
+                <p:cNvSpPr txBox="1"/>
+                <p:nvPr/>
+              </p:nvSpPr>
+              <p:spPr>
+                <a:xfrm>
+                  <a:off x="2389863" y="19913868"/>
+                  <a:ext cx="1006032" cy="831516"/>
+                </a:xfrm>
+                <a:prstGeom prst="rect">
+                  <a:avLst/>
+                </a:prstGeom>
+                <a:noFill/>
+              </p:spPr>
+              <p:txBody>
+                <a:bodyPr wrap="none" rtlCol="0" anchor="ctr">
+                  <a:spAutoFit/>
+                </a:bodyPr>
+                <a:lstStyle/>
+                <a:p>
+                  <a:r>
+                    <a:rPr lang="en-US" altLang="ko-KR" sz="4800" dirty="0">
+                      <a:solidFill>
+                        <a:schemeClr val="accent2"/>
+                      </a:solidFill>
+                      <a:latin typeface="페이퍼로지 8 ExtraBold" pitchFamily="2" charset="-127"/>
+                      <a:ea typeface="페이퍼로지 8 ExtraBold" pitchFamily="2" charset="-127"/>
+                    </a:rPr>
+                    <a:t>04</a:t>
+                  </a:r>
+                  <a:endParaRPr lang="ko-KR" altLang="en-US" sz="4800" dirty="0">
                     <a:solidFill>
                       <a:schemeClr val="accent2"/>
                     </a:solidFill>
                     <a:latin typeface="페이퍼로지 8 ExtraBold" pitchFamily="2" charset="-127"/>
                     <a:ea typeface="페이퍼로지 8 ExtraBold" pitchFamily="2" charset="-127"/>
-                  </a:rPr>
-                  <a:t>04</a:t>
-                </a:r>
-                <a:endParaRPr lang="ko-KR" altLang="en-US" sz="4800" dirty="0">
-                  <a:solidFill>
-                    <a:schemeClr val="accent2"/>
-                  </a:solidFill>
-                  <a:latin typeface="페이퍼로지 8 ExtraBold" pitchFamily="2" charset="-127"/>
-                  <a:ea typeface="페이퍼로지 8 ExtraBold" pitchFamily="2" charset="-127"/>
-                </a:endParaRPr>
-              </a:p>
-            </p:txBody>
-          </p:sp>
-          <p:sp>
-            <p:nvSpPr>
-              <p:cNvPr id="10" name="TextBox 9">
+                  </a:endParaRPr>
+                </a:p>
+              </p:txBody>
+            </p:sp>
+            <p:sp>
+              <p:nvSpPr>
+                <p:cNvPr id="10" name="TextBox 9">
+                  <a:extLst>
+                    <a:ext uri="{FF2B5EF4-FFF2-40B4-BE49-F238E27FC236}">
+                      <a16:creationId xmlns:a16="http://schemas.microsoft.com/office/drawing/2014/main" id="{5263F6F6-147D-D674-9B6C-0C88F173C7C7}"/>
+                    </a:ext>
+                  </a:extLst>
+                </p:cNvPr>
+                <p:cNvSpPr txBox="1"/>
+                <p:nvPr/>
+              </p:nvSpPr>
+              <p:spPr>
+                <a:xfrm>
+                  <a:off x="6408555" y="19933866"/>
+                  <a:ext cx="5302414" cy="707886"/>
+                </a:xfrm>
+                <a:prstGeom prst="rect">
+                  <a:avLst/>
+                </a:prstGeom>
+                <a:noFill/>
+              </p:spPr>
+              <p:txBody>
+                <a:bodyPr wrap="square" lIns="72000" tIns="36000" rIns="72000" bIns="36000" rtlCol="0" anchor="t">
+                  <a:normAutofit/>
+                </a:bodyPr>
+                <a:lstStyle/>
+                <a:p>
+                  <a:pPr marL="720000" lvl="0" indent="-720000" defTabSz="2159996" latinLnBrk="1">
+                    <a:spcAft>
+                      <a:spcPts val="1200"/>
+                    </a:spcAft>
+                  </a:pPr>
+                  <a:r>
+                    <a:rPr lang="ko-KR" altLang="en-US" sz="4000" dirty="0">
+                      <a:solidFill>
+                        <a:schemeClr val="tx1">
+                          <a:lumMod val="95000"/>
+                          <a:lumOff val="5000"/>
+                        </a:schemeClr>
+                      </a:solidFill>
+                    </a:rPr>
+                    <a:t>각 파트별 구현 이미지</a:t>
+                  </a:r>
+                </a:p>
+              </p:txBody>
+            </p:sp>
+            <p:pic>
+              <p:nvPicPr>
+                <p:cNvPr id="20" name="그림 19" descr="The image is a textual representation of a user interface, displaying a menu with options and a Korean language question about parameter passing in Python.&#10;&#10;AI 생성 콘텐츠는 정확하지 않을 수 있습니다.">
+                  <a:extLst>
+                    <a:ext uri="{FF2B5EF4-FFF2-40B4-BE49-F238E27FC236}">
+                      <a16:creationId xmlns:a16="http://schemas.microsoft.com/office/drawing/2014/main" id="{E2DF2922-EA53-3A17-0C0B-6638611D242C}"/>
+                    </a:ext>
+                  </a:extLst>
+                </p:cNvPr>
+                <p:cNvPicPr>
+                  <a:picLocks noChangeAspect="1"/>
+                </p:cNvPicPr>
+                <p:nvPr/>
+              </p:nvPicPr>
+              <p:blipFill>
+                <a:blip r:embed="rId3"/>
+                <a:stretch>
+                  <a:fillRect/>
+                </a:stretch>
+              </p:blipFill>
+              <p:spPr>
+                <a:xfrm>
+                  <a:off x="5687194" y="24639618"/>
+                  <a:ext cx="5235905" cy="3600000"/>
+                </a:xfrm>
+                <a:prstGeom prst="rect">
+                  <a:avLst/>
+                </a:prstGeom>
+              </p:spPr>
+            </p:pic>
+            <p:pic>
+              <p:nvPicPr>
+                <p:cNvPr id="26" name="그림 25" descr="The image is a list of Python problems, categorized by levels (Lv.2 or Lv.3), including topics like input(), ord(), string formatting, function arguments, return statements, and variable types.&#10;&#10;AI 생성 콘텐츠는 정확하지 않을 수 있습니다.">
+                  <a:extLst>
+                    <a:ext uri="{FF2B5EF4-FFF2-40B4-BE49-F238E27FC236}">
+                      <a16:creationId xmlns:a16="http://schemas.microsoft.com/office/drawing/2014/main" id="{6BBF4A63-5C58-8271-B0B8-8DC1774639A0}"/>
+                    </a:ext>
+                  </a:extLst>
+                </p:cNvPr>
+                <p:cNvPicPr>
+                  <a:picLocks noChangeAspect="1"/>
+                </p:cNvPicPr>
+                <p:nvPr/>
+              </p:nvPicPr>
+              <p:blipFill>
+                <a:blip r:embed="rId4"/>
+                <a:stretch>
+                  <a:fillRect/>
+                </a:stretch>
+              </p:blipFill>
+              <p:spPr>
+                <a:xfrm>
+                  <a:off x="11555284" y="24615132"/>
+                  <a:ext cx="6840507" cy="3600000"/>
+                </a:xfrm>
+                <a:prstGeom prst="rect">
+                  <a:avLst/>
+                </a:prstGeom>
+              </p:spPr>
+            </p:pic>
+            <p:pic>
+              <p:nvPicPr>
+                <p:cNvPr id="30" name="그림 29" descr="The image shows a text input prompt on a Korean screen asking to identify which data type is not a built-in type in Python, with the options including 'rational' and a few other types.&#10;&#10;AI 생성 콘텐츠는 정확하지 않을 수 있습니다.">
+                  <a:extLst>
+                    <a:ext uri="{FF2B5EF4-FFF2-40B4-BE49-F238E27FC236}">
+                      <a16:creationId xmlns:a16="http://schemas.microsoft.com/office/drawing/2014/main" id="{02CCED8B-AFDA-25FD-87F4-CD1CCA35EE46}"/>
+                    </a:ext>
+                  </a:extLst>
+                </p:cNvPr>
+                <p:cNvPicPr>
+                  <a:picLocks noChangeAspect="1"/>
+                </p:cNvPicPr>
+                <p:nvPr/>
+              </p:nvPicPr>
+              <p:blipFill>
+                <a:blip r:embed="rId5"/>
+                <a:stretch>
+                  <a:fillRect/>
+                </a:stretch>
+              </p:blipFill>
+              <p:spPr>
+                <a:xfrm>
+                  <a:off x="5954552" y="20592132"/>
+                  <a:ext cx="7002312" cy="3600000"/>
+                </a:xfrm>
+                <a:prstGeom prst="rect">
+                  <a:avLst/>
+                </a:prstGeom>
+              </p:spPr>
+            </p:pic>
+          </p:grpSp>
+          <p:pic>
+            <p:nvPicPr>
+              <p:cNvPr id="3" name="그림 2" descr="The image depicts a simple ASCII representation of a Pokￃﾩmon, specifically Chimchar, with a timer showing 107 seconds, a score of 100, and a boss monster with 92/100 health remaining, alongside a multiple-choice question about string slicing in programming.&#10;&#10;AI 생성 콘텐츠는 정확하지 않을 수 있습니다.">
                 <a:extLst>
                   <a:ext uri="{FF2B5EF4-FFF2-40B4-BE49-F238E27FC236}">
-                    <a16:creationId xmlns:a16="http://schemas.microsoft.com/office/drawing/2014/main" id="{5263F6F6-147D-D674-9B6C-0C88F173C7C7}"/>
-                  </a:ext>
-                </a:extLst>
-              </p:cNvPr>
-              <p:cNvSpPr txBox="1"/>
-              <p:nvPr/>
-            </p:nvSpPr>
-            <p:spPr>
-              <a:xfrm>
-                <a:off x="6408555" y="19933866"/>
-                <a:ext cx="5302414" cy="707886"/>
-              </a:xfrm>
-              <a:prstGeom prst="rect">
-                <a:avLst/>
-              </a:prstGeom>
-              <a:noFill/>
-            </p:spPr>
-            <p:txBody>
-              <a:bodyPr wrap="square" lIns="72000" tIns="36000" rIns="72000" bIns="36000" rtlCol="0" anchor="t">
-                <a:normAutofit/>
-              </a:bodyPr>
-              <a:lstStyle/>
-              <a:p>
-                <a:pPr marL="720000" lvl="0" indent="-720000" defTabSz="2159996" latinLnBrk="1">
-                  <a:spcAft>
-                    <a:spcPts val="1200"/>
-                  </a:spcAft>
-                </a:pPr>
-                <a:r>
-                  <a:rPr lang="ko-KR" altLang="en-US" sz="4000" dirty="0">
-                    <a:solidFill>
-                      <a:schemeClr val="tx1">
-                        <a:lumMod val="95000"/>
-                        <a:lumOff val="5000"/>
-                      </a:schemeClr>
-                    </a:solidFill>
-                  </a:rPr>
-                  <a:t>각 파트별 구현 이미지</a:t>
-                </a:r>
-              </a:p>
-            </p:txBody>
-          </p:sp>
-          <p:pic>
-            <p:nvPicPr>
-              <p:cNvPr id="20" name="그림 19" descr="The image is a textual representation of a user interface, displaying a menu with options and a Korean language question about parameter passing in Python.&#10;&#10;AI 생성 콘텐츠는 정확하지 않을 수 있습니다.">
-                <a:extLst>
-                  <a:ext uri="{FF2B5EF4-FFF2-40B4-BE49-F238E27FC236}">
-                    <a16:creationId xmlns:a16="http://schemas.microsoft.com/office/drawing/2014/main" id="{E2DF2922-EA53-3A17-0C0B-6638611D242C}"/>
+                    <a16:creationId xmlns:a16="http://schemas.microsoft.com/office/drawing/2014/main" id="{85F9278A-B2BC-CFFD-8DEE-C110BA23E4CF}"/>
                   </a:ext>
                 </a:extLst>
               </p:cNvPr>
@@ -28196,75 +29712,15 @@
               <p:nvPr/>
             </p:nvPicPr>
             <p:blipFill>
-              <a:blip r:embed="rId3"/>
+              <a:blip r:embed="rId6"/>
               <a:stretch>
                 <a:fillRect/>
               </a:stretch>
             </p:blipFill>
             <p:spPr>
               <a:xfrm>
-                <a:off x="6122380" y="25065728"/>
-                <a:ext cx="5235905" cy="3600000"/>
-              </a:xfrm>
-              <a:prstGeom prst="rect">
-                <a:avLst/>
-              </a:prstGeom>
-            </p:spPr>
-          </p:pic>
-          <p:pic>
-            <p:nvPicPr>
-              <p:cNvPr id="26" name="그림 25" descr="The image is a list of Python problems, categorized by levels (Lv.2 or Lv.3), including topics like input(), ord(), string formatting, function arguments, return statements, and variable types.&#10;&#10;AI 생성 콘텐츠는 정확하지 않을 수 있습니다.">
-                <a:extLst>
-                  <a:ext uri="{FF2B5EF4-FFF2-40B4-BE49-F238E27FC236}">
-                    <a16:creationId xmlns:a16="http://schemas.microsoft.com/office/drawing/2014/main" id="{6BBF4A63-5C58-8271-B0B8-8DC1774639A0}"/>
-                  </a:ext>
-                </a:extLst>
-              </p:cNvPr>
-              <p:cNvPicPr>
-                <a:picLocks noChangeAspect="1"/>
-              </p:cNvPicPr>
-              <p:nvPr/>
-            </p:nvPicPr>
-            <p:blipFill>
-              <a:blip r:embed="rId4"/>
-              <a:stretch>
-                <a:fillRect/>
-              </a:stretch>
-            </p:blipFill>
-            <p:spPr>
-              <a:xfrm>
-                <a:off x="11990470" y="25041242"/>
-                <a:ext cx="6840507" cy="3600000"/>
-              </a:xfrm>
-              <a:prstGeom prst="rect">
-                <a:avLst/>
-              </a:prstGeom>
-            </p:spPr>
-          </p:pic>
-          <p:pic>
-            <p:nvPicPr>
-              <p:cNvPr id="30" name="그림 29" descr="The image shows a text input prompt on a Korean screen asking to identify which data type is not a built-in type in Python, with the options including 'rational' and a few other types.&#10;&#10;AI 생성 콘텐츠는 정확하지 않을 수 있습니다.">
-                <a:extLst>
-                  <a:ext uri="{FF2B5EF4-FFF2-40B4-BE49-F238E27FC236}">
-                    <a16:creationId xmlns:a16="http://schemas.microsoft.com/office/drawing/2014/main" id="{02CCED8B-AFDA-25FD-87F4-CD1CCA35EE46}"/>
-                  </a:ext>
-                </a:extLst>
-              </p:cNvPr>
-              <p:cNvPicPr>
-                <a:picLocks noChangeAspect="1"/>
-              </p:cNvPicPr>
-              <p:nvPr/>
-            </p:nvPicPr>
-            <p:blipFill>
-              <a:blip r:embed="rId5"/>
-              <a:stretch>
-                <a:fillRect/>
-              </a:stretch>
-            </p:blipFill>
-            <p:spPr>
-              <a:xfrm>
-                <a:off x="6389738" y="21018242"/>
-                <a:ext cx="7002312" cy="3600000"/>
+                <a:off x="14662404" y="20592132"/>
+                <a:ext cx="3046988" cy="3600000"/>
               </a:xfrm>
               <a:prstGeom prst="rect">
                 <a:avLst/>
@@ -28272,36 +29728,6 @@
             </p:spPr>
           </p:pic>
         </p:grpSp>
-        <p:pic>
-          <p:nvPicPr>
-            <p:cNvPr id="3" name="그림 2" descr="The image depicts a simple ASCII representation of a Pokￃﾩmon, specifically Chimchar, with a timer showing 107 seconds, a score of 100, and a boss monster with 92/100 health remaining, alongside a multiple-choice question about string slicing in programming.&#10;&#10;AI 생성 콘텐츠는 정확하지 않을 수 있습니다.">
-              <a:extLst>
-                <a:ext uri="{FF2B5EF4-FFF2-40B4-BE49-F238E27FC236}">
-                  <a16:creationId xmlns:a16="http://schemas.microsoft.com/office/drawing/2014/main" id="{85F9278A-B2BC-CFFD-8DEE-C110BA23E4CF}"/>
-                </a:ext>
-              </a:extLst>
-            </p:cNvPr>
-            <p:cNvPicPr>
-              <a:picLocks noChangeAspect="1"/>
-            </p:cNvPicPr>
-            <p:nvPr/>
-          </p:nvPicPr>
-          <p:blipFill>
-            <a:blip r:embed="rId6"/>
-            <a:stretch>
-              <a:fillRect/>
-            </a:stretch>
-          </p:blipFill>
-          <p:spPr>
-            <a:xfrm>
-              <a:off x="15097590" y="21018242"/>
-              <a:ext cx="3046988" cy="3600000"/>
-            </a:xfrm>
-            <a:prstGeom prst="rect">
-              <a:avLst/>
-            </a:prstGeom>
-          </p:spPr>
-        </p:pic>
       </p:grpSp>
       <p:grpSp>
         <p:nvGrpSpPr>

</xml_diff>